<commit_message>
Re-skin comp matrices to the Lincoln black-and-gold theme
Keep Eastdil's matrix layout but recolor to match the rest of the deck: black
property-name headers, gold 'Closed' vs gray pipeline status bands, pale-gold
row labels, and the Lincoln gold tab + report band (with wordmark) replacing
the navy/teal Eastdil header.

Co-Authored-By: Claude Opus 4.8 <noreply@anthropic.com>
Claude-Session: https://claude.ai/code/session_01618gwRtNT4bFmajXdLmDkH
</commit_message>
<xml_diff>
--- a/equity-deck/2300_N_Street_NW_Investment_Overview.pptx
+++ b/equity-deck/2300_N_Street_NW_Investment_Overview.pptx
@@ -9945,36 +9945,45 @@
       </p:sp>
       <p:sp>
         <p:nvSpPr>
-          <p:cNvPr id="3" name="TextBox 2"/>
-          <p:cNvSpPr txBox="1"/>
+          <p:cNvPr id="3" name="Rectangle 2"/>
+          <p:cNvSpPr/>
           <p:nvPr/>
         </p:nvSpPr>
         <p:spPr>
           <a:xfrm>
-            <a:off x="5486400" y="182880"/>
-            <a:ext cx="3291840" cy="228600"/>
+            <a:off x="384048" y="128016"/>
+            <a:ext cx="1325880" cy="201168"/>
           </a:xfrm>
           <a:prstGeom prst="rect">
             <a:avLst/>
           </a:prstGeom>
-          <a:noFill/>
+          <a:solidFill>
+            <a:srgbClr val="F5B400"/>
+          </a:solidFill>
+          <a:ln>
+            <a:noFill/>
+          </a:ln>
+          <a:effectLst/>
         </p:spPr>
+        <p:style>
+          <a:lnRef idx="1">
+            <a:schemeClr val="accent1"/>
+          </a:lnRef>
+          <a:fillRef idx="3">
+            <a:schemeClr val="accent1"/>
+          </a:fillRef>
+          <a:effectRef idx="2">
+            <a:schemeClr val="accent1"/>
+          </a:effectRef>
+          <a:fontRef idx="minor">
+            <a:schemeClr val="lt1"/>
+          </a:fontRef>
+        </p:style>
         <p:txBody>
-          <a:bodyPr wrap="square" anchor="t" lIns="0" rIns="0" tIns="0" bIns="0">
-            <a:spAutoFit/>
-          </a:bodyPr>
+          <a:bodyPr rtlCol="0" anchor="ctr"/>
           <a:lstStyle/>
           <a:p>
-            <a:pPr algn="r"/>
-            <a:r>
-              <a:rPr sz="750" b="1" i="0">
-                <a:solidFill>
-                  <a:srgbClr val="595959"/>
-                </a:solidFill>
-                <a:latin typeface="Calibri"/>
-              </a:rPr>
-              <a:t>2300 N STREET, NW  |  ES OPINION OF VALUE  |  JUN-26</a:t>
-            </a:r>
+            <a:pPr algn="ctr"/>
           </a:p>
         </p:txBody>
       </p:sp>
@@ -9986,8 +9995,8 @@
         </p:nvSpPr>
         <p:spPr>
           <a:xfrm>
-            <a:off x="384048" y="384048"/>
-            <a:ext cx="8229600" cy="502920"/>
+            <a:off x="365760" y="274320"/>
+            <a:ext cx="8229600" cy="685800"/>
           </a:xfrm>
           <a:prstGeom prst="rect">
             <a:avLst/>
@@ -10002,55 +10011,20 @@
           <a:p>
             <a:pPr algn="l"/>
             <a:r>
-              <a:rPr sz="2700" b="1" i="0">
+              <a:rPr sz="3200" b="0" i="0">
                 <a:solidFill>
-                  <a:srgbClr val="1F3864"/>
+                  <a:srgbClr val="262626"/>
                 </a:solidFill>
-                <a:latin typeface="Calibri"/>
+                <a:latin typeface="Calibri Light"/>
               </a:rPr>
-              <a:t>Washington, DC Recent Data Points</a:t>
-            </a:r>
-          </a:p>
-        </p:txBody>
-      </p:sp>
-      <p:sp>
-        <p:nvSpPr>
-          <p:cNvPr id="5" name="TextBox 4"/>
-          <p:cNvSpPr txBox="1"/>
-          <p:nvPr/>
-        </p:nvSpPr>
-        <p:spPr>
-          <a:xfrm>
-            <a:off x="402336" y="896112"/>
-            <a:ext cx="8229600" cy="365760"/>
-          </a:xfrm>
-          <a:prstGeom prst="rect">
-            <a:avLst/>
-          </a:prstGeom>
-          <a:noFill/>
-        </p:spPr>
-        <p:txBody>
-          <a:bodyPr wrap="square" anchor="t" lIns="0" rIns="0" tIns="0" bIns="0">
-            <a:spAutoFit/>
-          </a:bodyPr>
-          <a:lstStyle/>
-          <a:p>
-            <a:pPr algn="l"/>
-            <a:r>
-              <a:rPr sz="1700" b="1" i="0">
-                <a:solidFill>
-                  <a:srgbClr val="2CA9C7"/>
-                </a:solidFill>
-                <a:latin typeface="Calibri"/>
-              </a:rPr>
-              <a:t>Class-A</a:t>
+              <a:t>Recent Data Points</a:t>
             </a:r>
           </a:p>
         </p:txBody>
       </p:sp>
       <p:cxnSp>
         <p:nvCxnSpPr>
-          <p:cNvPr id="6" name="Connector 5"/>
+          <p:cNvPr id="5" name="Connector 4"/>
           <p:cNvCxnSpPr/>
           <p:nvPr/>
         </p:nvCxnSpPr>
@@ -10085,7 +10059,7 @@
       </p:cxnSp>
       <p:sp>
         <p:nvSpPr>
-          <p:cNvPr id="7" name="TextBox 6"/>
+          <p:cNvPr id="6" name="TextBox 5"/>
           <p:cNvSpPr txBox="1"/>
           <p:nvPr/>
         </p:nvSpPr>
@@ -10120,7 +10094,7 @@
       </p:sp>
       <p:sp>
         <p:nvSpPr>
-          <p:cNvPr id="8" name="TextBox 7"/>
+          <p:cNvPr id="7" name="TextBox 6"/>
           <p:cNvSpPr txBox="1"/>
           <p:nvPr/>
         </p:nvSpPr>
@@ -10153,17 +10127,166 @@
           </a:p>
         </p:txBody>
       </p:sp>
+      <p:sp>
+        <p:nvSpPr>
+          <p:cNvPr id="8" name="Rectangle 7"/>
+          <p:cNvSpPr/>
+          <p:nvPr/>
+        </p:nvSpPr>
+        <p:spPr>
+          <a:xfrm>
+            <a:off x="384048" y="914400"/>
+            <a:ext cx="8375904" cy="566928"/>
+          </a:xfrm>
+          <a:prstGeom prst="rect">
+            <a:avLst/>
+          </a:prstGeom>
+          <a:solidFill>
+            <a:srgbClr val="F5B400"/>
+          </a:solidFill>
+          <a:ln>
+            <a:noFill/>
+          </a:ln>
+          <a:effectLst/>
+        </p:spPr>
+        <p:style>
+          <a:lnRef idx="1">
+            <a:schemeClr val="accent1"/>
+          </a:lnRef>
+          <a:fillRef idx="3">
+            <a:schemeClr val="accent1"/>
+          </a:fillRef>
+          <a:effectRef idx="2">
+            <a:schemeClr val="accent1"/>
+          </a:effectRef>
+          <a:fontRef idx="minor">
+            <a:schemeClr val="lt1"/>
+          </a:fontRef>
+        </p:style>
+        <p:txBody>
+          <a:bodyPr rtlCol="0" anchor="ctr"/>
+          <a:lstStyle/>
+          <a:p>
+            <a:pPr algn="ctr"/>
+          </a:p>
+        </p:txBody>
+      </p:sp>
+      <p:sp>
+        <p:nvSpPr>
+          <p:cNvPr id="9" name="TextBox 8"/>
+          <p:cNvSpPr txBox="1"/>
+          <p:nvPr/>
+        </p:nvSpPr>
+        <p:spPr>
+          <a:xfrm>
+            <a:off x="548640" y="978408"/>
+            <a:ext cx="5943600" cy="274320"/>
+          </a:xfrm>
+          <a:prstGeom prst="rect">
+            <a:avLst/>
+          </a:prstGeom>
+          <a:noFill/>
+        </p:spPr>
+        <p:txBody>
+          <a:bodyPr wrap="square" anchor="t" lIns="0" rIns="0" tIns="0" bIns="0">
+            <a:spAutoFit/>
+          </a:bodyPr>
+          <a:lstStyle/>
+          <a:p>
+            <a:pPr algn="l"/>
+            <a:r>
+              <a:rPr sz="1250" b="1" i="0">
+                <a:solidFill>
+                  <a:srgbClr val="3D3000"/>
+                </a:solidFill>
+                <a:latin typeface="Calibri"/>
+              </a:rPr>
+              <a:t>WASHINGTON, DC — CLASS-A SALES</a:t>
+            </a:r>
+          </a:p>
+        </p:txBody>
+      </p:sp>
+      <p:sp>
+        <p:nvSpPr>
+          <p:cNvPr id="10" name="TextBox 9"/>
+          <p:cNvSpPr txBox="1"/>
+          <p:nvPr/>
+        </p:nvSpPr>
+        <p:spPr>
+          <a:xfrm>
+            <a:off x="548640" y="1216152"/>
+            <a:ext cx="5943600" cy="228600"/>
+          </a:xfrm>
+          <a:prstGeom prst="rect">
+            <a:avLst/>
+          </a:prstGeom>
+          <a:noFill/>
+        </p:spPr>
+        <p:txBody>
+          <a:bodyPr wrap="square" anchor="t" lIns="0" rIns="0" tIns="0" bIns="0">
+            <a:spAutoFit/>
+          </a:bodyPr>
+          <a:lstStyle/>
+          <a:p>
+            <a:pPr algn="l"/>
+            <a:r>
+              <a:rPr sz="1000" b="0" i="1">
+                <a:solidFill>
+                  <a:srgbClr val="3D3000"/>
+                </a:solidFill>
+                <a:latin typeface="Calibri"/>
+              </a:rPr>
+              <a:t>Recent &amp; Active Comparable Transactions</a:t>
+            </a:r>
+          </a:p>
+        </p:txBody>
+      </p:sp>
+      <p:sp>
+        <p:nvSpPr>
+          <p:cNvPr id="11" name="TextBox 10"/>
+          <p:cNvSpPr txBox="1"/>
+          <p:nvPr/>
+        </p:nvSpPr>
+        <p:spPr>
+          <a:xfrm>
+            <a:off x="6766560" y="1005840"/>
+            <a:ext cx="1828800" cy="365760"/>
+          </a:xfrm>
+          <a:prstGeom prst="rect">
+            <a:avLst/>
+          </a:prstGeom>
+          <a:noFill/>
+        </p:spPr>
+        <p:txBody>
+          <a:bodyPr wrap="square" anchor="t" lIns="0" rIns="0" tIns="0" bIns="0">
+            <a:spAutoFit/>
+          </a:bodyPr>
+          <a:lstStyle/>
+          <a:p>
+            <a:pPr algn="r"/>
+            <a:r>
+              <a:rPr sz="2400" b="1" i="0">
+                <a:solidFill>
+                  <a:srgbClr val="3D3000"/>
+                </a:solidFill>
+                <a:latin typeface="Georgia"/>
+              </a:rPr>
+              <a:t>Lincoln</a:t>
+            </a:r>
+          </a:p>
+        </p:txBody>
+      </p:sp>
       <p:graphicFrame>
         <p:nvGraphicFramePr>
-          <p:cNvPr id="9" name="Table 8"/>
+          <p:cNvPr id="12" name="Table 11"/>
           <p:cNvGraphicFramePr>
             <a:graphicFrameLocks noGrp="1"/>
           </p:cNvGraphicFramePr>
           <p:nvPr/>
         </p:nvGraphicFramePr>
         <p:xfrm>
-          <a:off x="384048" y="1371600"/>
-          <a:ext cx="8375903" cy="3310120"/>
+          <a:off x="384048" y="1572768"/>
+          <a:ext cx="8375903" cy="3108960"/>
         </p:xfrm>
         <a:graphic>
           <a:graphicData uri="http://schemas.openxmlformats.org/drawingml/2006/table">
@@ -10185,7 +10308,7 @@
                 <a:gridCol w="679981"/>
                 <a:gridCol w="679981"/>
               </a:tblGrid>
-              <a:tr h="457200">
+              <a:tr h="438912">
                 <a:tc>
                   <a:txBody>
                     <a:bodyPr wrap="square"/>
@@ -10228,7 +10351,7 @@
                   </a:txBody>
                   <a:tcPr anchor="ctr" marL="45720" marR="36576" marT="9144" marB="9144">
                     <a:solidFill>
-                      <a:srgbClr val="1F3864"/>
+                      <a:srgbClr val="222222"/>
                     </a:solidFill>
                   </a:tcPr>
                 </a:tc>
@@ -10251,7 +10374,7 @@
                   </a:txBody>
                   <a:tcPr anchor="ctr" marL="45720" marR="36576" marT="9144" marB="9144">
                     <a:solidFill>
-                      <a:srgbClr val="1F3864"/>
+                      <a:srgbClr val="222222"/>
                     </a:solidFill>
                   </a:tcPr>
                 </a:tc>
@@ -10274,7 +10397,7 @@
                   </a:txBody>
                   <a:tcPr anchor="ctr" marL="45720" marR="36576" marT="9144" marB="9144">
                     <a:solidFill>
-                      <a:srgbClr val="1F3864"/>
+                      <a:srgbClr val="222222"/>
                     </a:solidFill>
                   </a:tcPr>
                 </a:tc>
@@ -10297,7 +10420,7 @@
                   </a:txBody>
                   <a:tcPr anchor="ctr" marL="45720" marR="36576" marT="9144" marB="9144">
                     <a:solidFill>
-                      <a:srgbClr val="1F3864"/>
+                      <a:srgbClr val="222222"/>
                     </a:solidFill>
                   </a:tcPr>
                 </a:tc>
@@ -10320,7 +10443,7 @@
                   </a:txBody>
                   <a:tcPr anchor="ctr" marL="45720" marR="36576" marT="9144" marB="9144">
                     <a:solidFill>
-                      <a:srgbClr val="1F3864"/>
+                      <a:srgbClr val="222222"/>
                     </a:solidFill>
                   </a:tcPr>
                 </a:tc>
@@ -10343,7 +10466,7 @@
                   </a:txBody>
                   <a:tcPr anchor="ctr" marL="45720" marR="36576" marT="9144" marB="9144">
                     <a:solidFill>
-                      <a:srgbClr val="1F3864"/>
+                      <a:srgbClr val="222222"/>
                     </a:solidFill>
                   </a:tcPr>
                 </a:tc>
@@ -10366,7 +10489,7 @@
                   </a:txBody>
                   <a:tcPr anchor="ctr" marL="45720" marR="36576" marT="9144" marB="9144">
                     <a:solidFill>
-                      <a:srgbClr val="1F3864"/>
+                      <a:srgbClr val="222222"/>
                     </a:solidFill>
                   </a:tcPr>
                 </a:tc>
@@ -10401,7 +10524,7 @@
                   </a:txBody>
                   <a:tcPr anchor="ctr" marL="45720" marR="36576" marT="9144" marB="9144">
                     <a:solidFill>
-                      <a:srgbClr val="1F3864"/>
+                      <a:srgbClr val="222222"/>
                     </a:solidFill>
                   </a:tcPr>
                 </a:tc>
@@ -10436,7 +10559,7 @@
                   </a:txBody>
                   <a:tcPr anchor="ctr" marL="45720" marR="36576" marT="9144" marB="9144">
                     <a:solidFill>
-                      <a:srgbClr val="1F3864"/>
+                      <a:srgbClr val="222222"/>
                     </a:solidFill>
                   </a:tcPr>
                 </a:tc>
@@ -10459,7 +10582,7 @@
                   </a:txBody>
                   <a:tcPr anchor="ctr" marL="45720" marR="36576" marT="9144" marB="9144">
                     <a:solidFill>
-                      <a:srgbClr val="1F3864"/>
+                      <a:srgbClr val="222222"/>
                     </a:solidFill>
                   </a:tcPr>
                 </a:tc>
@@ -10482,12 +10605,12 @@
                   </a:txBody>
                   <a:tcPr anchor="ctr" marL="45720" marR="36576" marT="9144" marB="9144">
                     <a:solidFill>
-                      <a:srgbClr val="1F3864"/>
+                      <a:srgbClr val="222222"/>
                     </a:solidFill>
                   </a:tcPr>
                 </a:tc>
               </a:tr>
-              <a:tr h="566928">
+              <a:tr h="512064">
                 <a:tc>
                   <a:txBody>
                     <a:bodyPr wrap="square"/>
@@ -10808,7 +10931,7 @@
                   </a:txBody>
                   <a:tcPr anchor="ctr" marL="45720" marR="36576" marT="9144" marB="9144">
                     <a:solidFill>
-                      <a:srgbClr val="2CA9C7"/>
+                      <a:srgbClr val="8C8C8C"/>
                     </a:solidFill>
                   </a:tcPr>
                 </a:tc>
@@ -10831,7 +10954,7 @@
                   </a:txBody>
                   <a:tcPr anchor="ctr" marL="45720" marR="36576" marT="9144" marB="9144">
                     <a:solidFill>
-                      <a:srgbClr val="2CA9C7"/>
+                      <a:srgbClr val="8C8C8C"/>
                     </a:solidFill>
                   </a:tcPr>
                 </a:tc>
@@ -10854,7 +10977,7 @@
                   </a:txBody>
                   <a:tcPr anchor="ctr" marL="45720" marR="36576" marT="9144" marB="9144">
                     <a:solidFill>
-                      <a:srgbClr val="2CA9C7"/>
+                      <a:srgbClr val="8C8C8C"/>
                     </a:solidFill>
                   </a:tcPr>
                 </a:tc>
@@ -10877,7 +11000,7 @@
                   </a:txBody>
                   <a:tcPr anchor="ctr" marL="45720" marR="36576" marT="9144" marB="9144">
                     <a:solidFill>
-                      <a:srgbClr val="2CA9C7"/>
+                      <a:srgbClr val="8C8C8C"/>
                     </a:solidFill>
                   </a:tcPr>
                 </a:tc>
@@ -10890,7 +11013,7 @@
                       <a:r>
                         <a:rPr sz="620" b="1" i="0">
                           <a:solidFill>
-                            <a:srgbClr val="FFFFFF"/>
+                            <a:srgbClr val="3D3000"/>
                           </a:solidFill>
                           <a:latin typeface="Calibri"/>
                         </a:rPr>
@@ -10900,7 +11023,7 @@
                   </a:txBody>
                   <a:tcPr anchor="ctr" marL="45720" marR="36576" marT="9144" marB="9144">
                     <a:solidFill>
-                      <a:srgbClr val="57A639"/>
+                      <a:srgbClr val="F5B400"/>
                     </a:solidFill>
                   </a:tcPr>
                 </a:tc>
@@ -10913,7 +11036,7 @@
                       <a:r>
                         <a:rPr sz="620" b="1" i="0">
                           <a:solidFill>
-                            <a:srgbClr val="FFFFFF"/>
+                            <a:srgbClr val="3D3000"/>
                           </a:solidFill>
                           <a:latin typeface="Calibri"/>
                         </a:rPr>
@@ -10923,7 +11046,7 @@
                   </a:txBody>
                   <a:tcPr anchor="ctr" marL="45720" marR="36576" marT="9144" marB="9144">
                     <a:solidFill>
-                      <a:srgbClr val="57A639"/>
+                      <a:srgbClr val="F5B400"/>
                     </a:solidFill>
                   </a:tcPr>
                 </a:tc>
@@ -10936,7 +11059,7 @@
                       <a:r>
                         <a:rPr sz="620" b="1" i="0">
                           <a:solidFill>
-                            <a:srgbClr val="FFFFFF"/>
+                            <a:srgbClr val="3D3000"/>
                           </a:solidFill>
                           <a:latin typeface="Calibri"/>
                         </a:rPr>
@@ -10946,7 +11069,7 @@
                   </a:txBody>
                   <a:tcPr anchor="ctr" marL="45720" marR="36576" marT="9144" marB="9144">
                     <a:solidFill>
-                      <a:srgbClr val="57A639"/>
+                      <a:srgbClr val="F5B400"/>
                     </a:solidFill>
                   </a:tcPr>
                 </a:tc>
@@ -10959,7 +11082,7 @@
                       <a:r>
                         <a:rPr sz="620" b="1" i="0">
                           <a:solidFill>
-                            <a:srgbClr val="FFFFFF"/>
+                            <a:srgbClr val="3D3000"/>
                           </a:solidFill>
                           <a:latin typeface="Calibri"/>
                         </a:rPr>
@@ -10969,7 +11092,7 @@
                   </a:txBody>
                   <a:tcPr anchor="ctr" marL="45720" marR="36576" marT="9144" marB="9144">
                     <a:solidFill>
-                      <a:srgbClr val="57A639"/>
+                      <a:srgbClr val="F5B400"/>
                     </a:solidFill>
                   </a:tcPr>
                 </a:tc>
@@ -10982,7 +11105,7 @@
                       <a:r>
                         <a:rPr sz="620" b="1" i="0">
                           <a:solidFill>
-                            <a:srgbClr val="FFFFFF"/>
+                            <a:srgbClr val="3D3000"/>
                           </a:solidFill>
                           <a:latin typeface="Calibri"/>
                         </a:rPr>
@@ -10992,7 +11115,7 @@
                   </a:txBody>
                   <a:tcPr anchor="ctr" marL="45720" marR="36576" marT="9144" marB="9144">
                     <a:solidFill>
-                      <a:srgbClr val="57A639"/>
+                      <a:srgbClr val="F5B400"/>
                     </a:solidFill>
                   </a:tcPr>
                 </a:tc>
@@ -11005,7 +11128,7 @@
                       <a:r>
                         <a:rPr sz="620" b="1" i="0">
                           <a:solidFill>
-                            <a:srgbClr val="FFFFFF"/>
+                            <a:srgbClr val="3D3000"/>
                           </a:solidFill>
                           <a:latin typeface="Calibri"/>
                         </a:rPr>
@@ -11015,7 +11138,7 @@
                   </a:txBody>
                   <a:tcPr anchor="ctr" marL="45720" marR="36576" marT="9144" marB="9144">
                     <a:solidFill>
-                      <a:srgbClr val="57A639"/>
+                      <a:srgbClr val="F5B400"/>
                     </a:solidFill>
                   </a:tcPr>
                 </a:tc>
@@ -11028,7 +11151,7 @@
                       <a:r>
                         <a:rPr sz="620" b="1" i="0">
                           <a:solidFill>
-                            <a:srgbClr val="FFFFFF"/>
+                            <a:srgbClr val="3D3000"/>
                           </a:solidFill>
                           <a:latin typeface="Calibri"/>
                         </a:rPr>
@@ -11038,12 +11161,12 @@
                   </a:txBody>
                   <a:tcPr anchor="ctr" marL="45720" marR="36576" marT="9144" marB="9144">
                     <a:solidFill>
-                      <a:srgbClr val="57A639"/>
+                      <a:srgbClr val="F5B400"/>
                     </a:solidFill>
                   </a:tcPr>
                 </a:tc>
               </a:tr>
-              <a:tr h="258317">
+              <a:tr h="242316">
                 <a:tc>
                   <a:txBody>
                     <a:bodyPr wrap="square"/>
@@ -11053,7 +11176,7 @@
                       <a:r>
                         <a:rPr sz="620" b="1" i="0">
                           <a:solidFill>
-                            <a:srgbClr val="1F3864"/>
+                            <a:srgbClr val="262626"/>
                           </a:solidFill>
                           <a:latin typeface="Calibri"/>
                         </a:rPr>
@@ -11063,7 +11186,7 @@
                   </a:txBody>
                   <a:tcPr anchor="ctr" marL="45720" marR="36576" marT="9144" marB="9144">
                     <a:solidFill>
-                      <a:srgbClr val="D9E2F3"/>
+                      <a:srgbClr val="FBEFCB"/>
                     </a:solidFill>
                   </a:tcPr>
                 </a:tc>
@@ -11321,7 +11444,7 @@
                   </a:tcPr>
                 </a:tc>
               </a:tr>
-              <a:tr h="258317">
+              <a:tr h="242316">
                 <a:tc>
                   <a:txBody>
                     <a:bodyPr wrap="square"/>
@@ -11331,7 +11454,7 @@
                       <a:r>
                         <a:rPr sz="620" b="1" i="0">
                           <a:solidFill>
-                            <a:srgbClr val="1F3864"/>
+                            <a:srgbClr val="262626"/>
                           </a:solidFill>
                           <a:latin typeface="Calibri"/>
                         </a:rPr>
@@ -11341,7 +11464,7 @@
                   </a:txBody>
                   <a:tcPr anchor="ctr" marL="45720" marR="36576" marT="9144" marB="9144">
                     <a:solidFill>
-                      <a:srgbClr val="D9E2F3"/>
+                      <a:srgbClr val="FBEFCB"/>
                     </a:solidFill>
                   </a:tcPr>
                 </a:tc>
@@ -11599,7 +11722,7 @@
                   </a:tcPr>
                 </a:tc>
               </a:tr>
-              <a:tr h="258317">
+              <a:tr h="242316">
                 <a:tc>
                   <a:txBody>
                     <a:bodyPr wrap="square"/>
@@ -11609,7 +11732,7 @@
                       <a:r>
                         <a:rPr sz="620" b="1" i="0">
                           <a:solidFill>
-                            <a:srgbClr val="1F3864"/>
+                            <a:srgbClr val="262626"/>
                           </a:solidFill>
                           <a:latin typeface="Calibri"/>
                         </a:rPr>
@@ -11619,7 +11742,7 @@
                   </a:txBody>
                   <a:tcPr anchor="ctr" marL="45720" marR="36576" marT="9144" marB="9144">
                     <a:solidFill>
-                      <a:srgbClr val="D9E2F3"/>
+                      <a:srgbClr val="FBEFCB"/>
                     </a:solidFill>
                   </a:tcPr>
                 </a:tc>
@@ -11877,7 +12000,7 @@
                   </a:tcPr>
                 </a:tc>
               </a:tr>
-              <a:tr h="258317">
+              <a:tr h="242316">
                 <a:tc>
                   <a:txBody>
                     <a:bodyPr wrap="square"/>
@@ -11887,7 +12010,7 @@
                       <a:r>
                         <a:rPr sz="620" b="1" i="0">
                           <a:solidFill>
-                            <a:srgbClr val="1F3864"/>
+                            <a:srgbClr val="262626"/>
                           </a:solidFill>
                           <a:latin typeface="Calibri"/>
                         </a:rPr>
@@ -11897,7 +12020,7 @@
                   </a:txBody>
                   <a:tcPr anchor="ctr" marL="45720" marR="36576" marT="9144" marB="9144">
                     <a:solidFill>
-                      <a:srgbClr val="D9E2F3"/>
+                      <a:srgbClr val="FBEFCB"/>
                     </a:solidFill>
                   </a:tcPr>
                 </a:tc>
@@ -12155,7 +12278,7 @@
                   </a:tcPr>
                 </a:tc>
               </a:tr>
-              <a:tr h="258317">
+              <a:tr h="242316">
                 <a:tc>
                   <a:txBody>
                     <a:bodyPr wrap="square"/>
@@ -12165,7 +12288,7 @@
                       <a:r>
                         <a:rPr sz="620" b="1" i="0">
                           <a:solidFill>
-                            <a:srgbClr val="1F3864"/>
+                            <a:srgbClr val="262626"/>
                           </a:solidFill>
                           <a:latin typeface="Calibri"/>
                         </a:rPr>
@@ -12175,7 +12298,7 @@
                   </a:txBody>
                   <a:tcPr anchor="ctr" marL="45720" marR="36576" marT="9144" marB="9144">
                     <a:solidFill>
-                      <a:srgbClr val="D9E2F3"/>
+                      <a:srgbClr val="FBEFCB"/>
                     </a:solidFill>
                   </a:tcPr>
                 </a:tc>
@@ -12565,7 +12688,7 @@
                   </a:tcPr>
                 </a:tc>
               </a:tr>
-              <a:tr h="258317">
+              <a:tr h="242316">
                 <a:tc>
                   <a:txBody>
                     <a:bodyPr wrap="square"/>
@@ -12575,7 +12698,7 @@
                       <a:r>
                         <a:rPr sz="620" b="1" i="0">
                           <a:solidFill>
-                            <a:srgbClr val="1F3864"/>
+                            <a:srgbClr val="262626"/>
                           </a:solidFill>
                           <a:latin typeface="Calibri"/>
                         </a:rPr>
@@ -12585,7 +12708,7 @@
                   </a:txBody>
                   <a:tcPr anchor="ctr" marL="45720" marR="36576" marT="9144" marB="9144">
                     <a:solidFill>
-                      <a:srgbClr val="D9E2F3"/>
+                      <a:srgbClr val="FBEFCB"/>
                     </a:solidFill>
                   </a:tcPr>
                 </a:tc>
@@ -12855,7 +12978,7 @@
                   </a:tcPr>
                 </a:tc>
               </a:tr>
-              <a:tr h="258317">
+              <a:tr h="242316">
                 <a:tc>
                   <a:txBody>
                     <a:bodyPr wrap="square"/>
@@ -12865,7 +12988,7 @@
                       <a:r>
                         <a:rPr sz="620" b="1" i="0">
                           <a:solidFill>
-                            <a:srgbClr val="1F3864"/>
+                            <a:srgbClr val="262626"/>
                           </a:solidFill>
                           <a:latin typeface="Calibri"/>
                         </a:rPr>
@@ -12875,7 +12998,7 @@
                   </a:txBody>
                   <a:tcPr anchor="ctr" marL="45720" marR="36576" marT="9144" marB="9144">
                     <a:solidFill>
-                      <a:srgbClr val="D9E2F3"/>
+                      <a:srgbClr val="FBEFCB"/>
                     </a:solidFill>
                   </a:tcPr>
                 </a:tc>
@@ -13205,7 +13328,7 @@
                   </a:tcPr>
                 </a:tc>
               </a:tr>
-              <a:tr h="258317">
+              <a:tr h="242316">
                 <a:tc>
                   <a:txBody>
                     <a:bodyPr wrap="square"/>
@@ -13215,7 +13338,7 @@
                       <a:r>
                         <a:rPr sz="620" b="1" i="0">
                           <a:solidFill>
-                            <a:srgbClr val="1F3864"/>
+                            <a:srgbClr val="262626"/>
                           </a:solidFill>
                           <a:latin typeface="Calibri"/>
                         </a:rPr>
@@ -13225,7 +13348,7 @@
                   </a:txBody>
                   <a:tcPr anchor="ctr" marL="45720" marR="36576" marT="9144" marB="9144">
                     <a:solidFill>
-                      <a:srgbClr val="D9E2F3"/>
+                      <a:srgbClr val="FBEFCB"/>
                     </a:solidFill>
                   </a:tcPr>
                 </a:tc>
@@ -13635,36 +13758,45 @@
       </p:sp>
       <p:sp>
         <p:nvSpPr>
-          <p:cNvPr id="3" name="TextBox 2"/>
-          <p:cNvSpPr txBox="1"/>
+          <p:cNvPr id="3" name="Rectangle 2"/>
+          <p:cNvSpPr/>
           <p:nvPr/>
         </p:nvSpPr>
         <p:spPr>
           <a:xfrm>
-            <a:off x="5486400" y="182880"/>
-            <a:ext cx="3291840" cy="228600"/>
+            <a:off x="384048" y="128016"/>
+            <a:ext cx="1325880" cy="201168"/>
           </a:xfrm>
           <a:prstGeom prst="rect">
             <a:avLst/>
           </a:prstGeom>
-          <a:noFill/>
+          <a:solidFill>
+            <a:srgbClr val="F5B400"/>
+          </a:solidFill>
+          <a:ln>
+            <a:noFill/>
+          </a:ln>
+          <a:effectLst/>
         </p:spPr>
+        <p:style>
+          <a:lnRef idx="1">
+            <a:schemeClr val="accent1"/>
+          </a:lnRef>
+          <a:fillRef idx="3">
+            <a:schemeClr val="accent1"/>
+          </a:fillRef>
+          <a:effectRef idx="2">
+            <a:schemeClr val="accent1"/>
+          </a:effectRef>
+          <a:fontRef idx="minor">
+            <a:schemeClr val="lt1"/>
+          </a:fontRef>
+        </p:style>
         <p:txBody>
-          <a:bodyPr wrap="square" anchor="t" lIns="0" rIns="0" tIns="0" bIns="0">
-            <a:spAutoFit/>
-          </a:bodyPr>
+          <a:bodyPr rtlCol="0" anchor="ctr"/>
           <a:lstStyle/>
           <a:p>
-            <a:pPr algn="r"/>
-            <a:r>
-              <a:rPr sz="750" b="1" i="0">
-                <a:solidFill>
-                  <a:srgbClr val="595959"/>
-                </a:solidFill>
-                <a:latin typeface="Calibri"/>
-              </a:rPr>
-              <a:t>2300 N STREET, NW  |  ES OPINION OF VALUE  |  JUN-26</a:t>
-            </a:r>
+            <a:pPr algn="ctr"/>
           </a:p>
         </p:txBody>
       </p:sp>
@@ -13676,8 +13808,8 @@
         </p:nvSpPr>
         <p:spPr>
           <a:xfrm>
-            <a:off x="384048" y="384048"/>
-            <a:ext cx="8229600" cy="502920"/>
+            <a:off x="365760" y="274320"/>
+            <a:ext cx="8229600" cy="685800"/>
           </a:xfrm>
           <a:prstGeom prst="rect">
             <a:avLst/>
@@ -13692,55 +13824,20 @@
           <a:p>
             <a:pPr algn="l"/>
             <a:r>
-              <a:rPr sz="2700" b="1" i="0">
+              <a:rPr sz="3200" b="0" i="0">
                 <a:solidFill>
-                  <a:srgbClr val="1F3864"/>
+                  <a:srgbClr val="262626"/>
                 </a:solidFill>
-                <a:latin typeface="Calibri"/>
+                <a:latin typeface="Calibri Light"/>
               </a:rPr>
-              <a:t>Washington, DC Recent Data Points</a:t>
-            </a:r>
-          </a:p>
-        </p:txBody>
-      </p:sp>
-      <p:sp>
-        <p:nvSpPr>
-          <p:cNvPr id="5" name="TextBox 4"/>
-          <p:cNvSpPr txBox="1"/>
-          <p:nvPr/>
-        </p:nvSpPr>
-        <p:spPr>
-          <a:xfrm>
-            <a:off x="402336" y="896112"/>
-            <a:ext cx="8229600" cy="365760"/>
-          </a:xfrm>
-          <a:prstGeom prst="rect">
-            <a:avLst/>
-          </a:prstGeom>
-          <a:noFill/>
-        </p:spPr>
-        <p:txBody>
-          <a:bodyPr wrap="square" anchor="t" lIns="0" rIns="0" tIns="0" bIns="0">
-            <a:spAutoFit/>
-          </a:bodyPr>
-          <a:lstStyle/>
-          <a:p>
-            <a:pPr algn="l"/>
-            <a:r>
-              <a:rPr sz="1700" b="1" i="0">
-                <a:solidFill>
-                  <a:srgbClr val="2CA9C7"/>
-                </a:solidFill>
-                <a:latin typeface="Calibri"/>
-              </a:rPr>
-              <a:t>Commodity</a:t>
+              <a:t>Recent Data Points</a:t>
             </a:r>
           </a:p>
         </p:txBody>
       </p:sp>
       <p:cxnSp>
         <p:nvCxnSpPr>
-          <p:cNvPr id="6" name="Connector 5"/>
+          <p:cNvPr id="5" name="Connector 4"/>
           <p:cNvCxnSpPr/>
           <p:nvPr/>
         </p:nvCxnSpPr>
@@ -13775,7 +13872,7 @@
       </p:cxnSp>
       <p:sp>
         <p:nvSpPr>
-          <p:cNvPr id="7" name="TextBox 6"/>
+          <p:cNvPr id="6" name="TextBox 5"/>
           <p:cNvSpPr txBox="1"/>
           <p:nvPr/>
         </p:nvSpPr>
@@ -13810,7 +13907,7 @@
       </p:sp>
       <p:sp>
         <p:nvSpPr>
-          <p:cNvPr id="8" name="TextBox 7"/>
+          <p:cNvPr id="7" name="TextBox 6"/>
           <p:cNvSpPr txBox="1"/>
           <p:nvPr/>
         </p:nvSpPr>
@@ -13843,17 +13940,166 @@
           </a:p>
         </p:txBody>
       </p:sp>
+      <p:sp>
+        <p:nvSpPr>
+          <p:cNvPr id="8" name="Rectangle 7"/>
+          <p:cNvSpPr/>
+          <p:nvPr/>
+        </p:nvSpPr>
+        <p:spPr>
+          <a:xfrm>
+            <a:off x="384048" y="914400"/>
+            <a:ext cx="8375904" cy="566928"/>
+          </a:xfrm>
+          <a:prstGeom prst="rect">
+            <a:avLst/>
+          </a:prstGeom>
+          <a:solidFill>
+            <a:srgbClr val="F5B400"/>
+          </a:solidFill>
+          <a:ln>
+            <a:noFill/>
+          </a:ln>
+          <a:effectLst/>
+        </p:spPr>
+        <p:style>
+          <a:lnRef idx="1">
+            <a:schemeClr val="accent1"/>
+          </a:lnRef>
+          <a:fillRef idx="3">
+            <a:schemeClr val="accent1"/>
+          </a:fillRef>
+          <a:effectRef idx="2">
+            <a:schemeClr val="accent1"/>
+          </a:effectRef>
+          <a:fontRef idx="minor">
+            <a:schemeClr val="lt1"/>
+          </a:fontRef>
+        </p:style>
+        <p:txBody>
+          <a:bodyPr rtlCol="0" anchor="ctr"/>
+          <a:lstStyle/>
+          <a:p>
+            <a:pPr algn="ctr"/>
+          </a:p>
+        </p:txBody>
+      </p:sp>
+      <p:sp>
+        <p:nvSpPr>
+          <p:cNvPr id="9" name="TextBox 8"/>
+          <p:cNvSpPr txBox="1"/>
+          <p:nvPr/>
+        </p:nvSpPr>
+        <p:spPr>
+          <a:xfrm>
+            <a:off x="548640" y="978408"/>
+            <a:ext cx="5943600" cy="274320"/>
+          </a:xfrm>
+          <a:prstGeom prst="rect">
+            <a:avLst/>
+          </a:prstGeom>
+          <a:noFill/>
+        </p:spPr>
+        <p:txBody>
+          <a:bodyPr wrap="square" anchor="t" lIns="0" rIns="0" tIns="0" bIns="0">
+            <a:spAutoFit/>
+          </a:bodyPr>
+          <a:lstStyle/>
+          <a:p>
+            <a:pPr algn="l"/>
+            <a:r>
+              <a:rPr sz="1250" b="1" i="0">
+                <a:solidFill>
+                  <a:srgbClr val="3D3000"/>
+                </a:solidFill>
+                <a:latin typeface="Calibri"/>
+              </a:rPr>
+              <a:t>WASHINGTON, DC — COMMODITY SALES</a:t>
+            </a:r>
+          </a:p>
+        </p:txBody>
+      </p:sp>
+      <p:sp>
+        <p:nvSpPr>
+          <p:cNvPr id="10" name="TextBox 9"/>
+          <p:cNvSpPr txBox="1"/>
+          <p:nvPr/>
+        </p:nvSpPr>
+        <p:spPr>
+          <a:xfrm>
+            <a:off x="548640" y="1216152"/>
+            <a:ext cx="5943600" cy="228600"/>
+          </a:xfrm>
+          <a:prstGeom prst="rect">
+            <a:avLst/>
+          </a:prstGeom>
+          <a:noFill/>
+        </p:spPr>
+        <p:txBody>
+          <a:bodyPr wrap="square" anchor="t" lIns="0" rIns="0" tIns="0" bIns="0">
+            <a:spAutoFit/>
+          </a:bodyPr>
+          <a:lstStyle/>
+          <a:p>
+            <a:pPr algn="l"/>
+            <a:r>
+              <a:rPr sz="1000" b="0" i="1">
+                <a:solidFill>
+                  <a:srgbClr val="3D3000"/>
+                </a:solidFill>
+                <a:latin typeface="Calibri"/>
+              </a:rPr>
+              <a:t>Recent &amp; Active Comparable Transactions</a:t>
+            </a:r>
+          </a:p>
+        </p:txBody>
+      </p:sp>
+      <p:sp>
+        <p:nvSpPr>
+          <p:cNvPr id="11" name="TextBox 10"/>
+          <p:cNvSpPr txBox="1"/>
+          <p:nvPr/>
+        </p:nvSpPr>
+        <p:spPr>
+          <a:xfrm>
+            <a:off x="6766560" y="1005840"/>
+            <a:ext cx="1828800" cy="365760"/>
+          </a:xfrm>
+          <a:prstGeom prst="rect">
+            <a:avLst/>
+          </a:prstGeom>
+          <a:noFill/>
+        </p:spPr>
+        <p:txBody>
+          <a:bodyPr wrap="square" anchor="t" lIns="0" rIns="0" tIns="0" bIns="0">
+            <a:spAutoFit/>
+          </a:bodyPr>
+          <a:lstStyle/>
+          <a:p>
+            <a:pPr algn="r"/>
+            <a:r>
+              <a:rPr sz="2400" b="1" i="0">
+                <a:solidFill>
+                  <a:srgbClr val="3D3000"/>
+                </a:solidFill>
+                <a:latin typeface="Georgia"/>
+              </a:rPr>
+              <a:t>Lincoln</a:t>
+            </a:r>
+          </a:p>
+        </p:txBody>
+      </p:sp>
       <p:graphicFrame>
         <p:nvGraphicFramePr>
-          <p:cNvPr id="9" name="Table 8"/>
+          <p:cNvPr id="12" name="Table 11"/>
           <p:cNvGraphicFramePr>
             <a:graphicFrameLocks noGrp="1"/>
           </p:cNvGraphicFramePr>
           <p:nvPr/>
         </p:nvGraphicFramePr>
         <p:xfrm>
-          <a:off x="384048" y="1325880"/>
-          <a:ext cx="8375898" cy="3355848"/>
+          <a:off x="384048" y="1572768"/>
+          <a:ext cx="8375898" cy="3108960"/>
         </p:xfrm>
         <a:graphic>
           <a:graphicData uri="http://schemas.openxmlformats.org/drawingml/2006/table">
@@ -13879,7 +14125,7 @@
                 <a:gridCol w="502310"/>
                 <a:gridCol w="502310"/>
               </a:tblGrid>
-              <a:tr h="457200">
+              <a:tr h="420624">
                 <a:tc>
                   <a:txBody>
                     <a:bodyPr wrap="square"/>
@@ -13922,7 +14168,7 @@
                   </a:txBody>
                   <a:tcPr anchor="ctr" marL="45720" marR="36576" marT="9144" marB="9144">
                     <a:solidFill>
-                      <a:srgbClr val="1F3864"/>
+                      <a:srgbClr val="222222"/>
                     </a:solidFill>
                   </a:tcPr>
                 </a:tc>
@@ -13945,7 +14191,7 @@
                   </a:txBody>
                   <a:tcPr anchor="ctr" marL="45720" marR="36576" marT="9144" marB="9144">
                     <a:solidFill>
-                      <a:srgbClr val="1F3864"/>
+                      <a:srgbClr val="222222"/>
                     </a:solidFill>
                   </a:tcPr>
                 </a:tc>
@@ -13968,7 +14214,7 @@
                   </a:txBody>
                   <a:tcPr anchor="ctr" marL="45720" marR="36576" marT="9144" marB="9144">
                     <a:solidFill>
-                      <a:srgbClr val="1F3864"/>
+                      <a:srgbClr val="222222"/>
                     </a:solidFill>
                   </a:tcPr>
                 </a:tc>
@@ -14003,7 +14249,7 @@
                   </a:txBody>
                   <a:tcPr anchor="ctr" marL="45720" marR="36576" marT="9144" marB="9144">
                     <a:solidFill>
-                      <a:srgbClr val="1F3864"/>
+                      <a:srgbClr val="222222"/>
                     </a:solidFill>
                   </a:tcPr>
                 </a:tc>
@@ -14026,7 +14272,7 @@
                   </a:txBody>
                   <a:tcPr anchor="ctr" marL="45720" marR="36576" marT="9144" marB="9144">
                     <a:solidFill>
-                      <a:srgbClr val="1F3864"/>
+                      <a:srgbClr val="222222"/>
                     </a:solidFill>
                   </a:tcPr>
                 </a:tc>
@@ -14049,7 +14295,7 @@
                   </a:txBody>
                   <a:tcPr anchor="ctr" marL="45720" marR="36576" marT="9144" marB="9144">
                     <a:solidFill>
-                      <a:srgbClr val="1F3864"/>
+                      <a:srgbClr val="222222"/>
                     </a:solidFill>
                   </a:tcPr>
                 </a:tc>
@@ -14072,7 +14318,7 @@
                   </a:txBody>
                   <a:tcPr anchor="ctr" marL="45720" marR="36576" marT="9144" marB="9144">
                     <a:solidFill>
-                      <a:srgbClr val="1F3864"/>
+                      <a:srgbClr val="222222"/>
                     </a:solidFill>
                   </a:tcPr>
                 </a:tc>
@@ -14095,7 +14341,7 @@
                   </a:txBody>
                   <a:tcPr anchor="ctr" marL="45720" marR="36576" marT="9144" marB="9144">
                     <a:solidFill>
-                      <a:srgbClr val="1F3864"/>
+                      <a:srgbClr val="222222"/>
                     </a:solidFill>
                   </a:tcPr>
                 </a:tc>
@@ -14118,7 +14364,7 @@
                   </a:txBody>
                   <a:tcPr anchor="ctr" marL="45720" marR="36576" marT="9144" marB="9144">
                     <a:solidFill>
-                      <a:srgbClr val="1F3864"/>
+                      <a:srgbClr val="222222"/>
                     </a:solidFill>
                   </a:tcPr>
                 </a:tc>
@@ -14141,7 +14387,7 @@
                   </a:txBody>
                   <a:tcPr anchor="ctr" marL="45720" marR="36576" marT="9144" marB="9144">
                     <a:solidFill>
-                      <a:srgbClr val="1F3864"/>
+                      <a:srgbClr val="222222"/>
                     </a:solidFill>
                   </a:tcPr>
                 </a:tc>
@@ -14164,7 +14410,7 @@
                   </a:txBody>
                   <a:tcPr anchor="ctr" marL="45720" marR="36576" marT="9144" marB="9144">
                     <a:solidFill>
-                      <a:srgbClr val="1F3864"/>
+                      <a:srgbClr val="222222"/>
                     </a:solidFill>
                   </a:tcPr>
                 </a:tc>
@@ -14187,7 +14433,7 @@
                   </a:txBody>
                   <a:tcPr anchor="ctr" marL="45720" marR="36576" marT="9144" marB="9144">
                     <a:solidFill>
-                      <a:srgbClr val="1F3864"/>
+                      <a:srgbClr val="222222"/>
                     </a:solidFill>
                   </a:tcPr>
                 </a:tc>
@@ -14210,7 +14456,7 @@
                   </a:txBody>
                   <a:tcPr anchor="ctr" marL="45720" marR="36576" marT="9144" marB="9144">
                     <a:solidFill>
-                      <a:srgbClr val="1F3864"/>
+                      <a:srgbClr val="222222"/>
                     </a:solidFill>
                   </a:tcPr>
                 </a:tc>
@@ -14233,7 +14479,7 @@
                   </a:txBody>
                   <a:tcPr anchor="ctr" marL="45720" marR="36576" marT="9144" marB="9144">
                     <a:solidFill>
-                      <a:srgbClr val="1F3864"/>
+                      <a:srgbClr val="222222"/>
                     </a:solidFill>
                   </a:tcPr>
                 </a:tc>
@@ -14256,12 +14502,12 @@
                   </a:txBody>
                   <a:tcPr anchor="ctr" marL="45720" marR="36576" marT="9144" marB="9144">
                     <a:solidFill>
-                      <a:srgbClr val="1F3864"/>
+                      <a:srgbClr val="222222"/>
                     </a:solidFill>
                   </a:tcPr>
                 </a:tc>
               </a:tr>
-              <a:tr h="457200">
+              <a:tr h="420624">
                 <a:tc>
                   <a:txBody>
                     <a:bodyPr wrap="square"/>
@@ -14631,7 +14877,7 @@
                   </a:tcPr>
                 </a:tc>
               </a:tr>
-              <a:tr h="310896">
+              <a:tr h="292608">
                 <a:tc>
                   <a:txBody>
                     <a:bodyPr wrap="square"/>
@@ -14674,7 +14920,7 @@
                   </a:txBody>
                   <a:tcPr anchor="ctr" marL="45720" marR="36576" marT="9144" marB="9144">
                     <a:solidFill>
-                      <a:srgbClr val="2CA9C7"/>
+                      <a:srgbClr val="8C8C8C"/>
                     </a:solidFill>
                   </a:tcPr>
                 </a:tc>
@@ -14697,7 +14943,7 @@
                   </a:txBody>
                   <a:tcPr anchor="ctr" marL="45720" marR="36576" marT="9144" marB="9144">
                     <a:solidFill>
-                      <a:srgbClr val="2CA9C7"/>
+                      <a:srgbClr val="8C8C8C"/>
                     </a:solidFill>
                   </a:tcPr>
                 </a:tc>
@@ -14720,7 +14966,7 @@
                   </a:txBody>
                   <a:tcPr anchor="ctr" marL="45720" marR="36576" marT="9144" marB="9144">
                     <a:solidFill>
-                      <a:srgbClr val="2CA9C7"/>
+                      <a:srgbClr val="8C8C8C"/>
                     </a:solidFill>
                   </a:tcPr>
                 </a:tc>
@@ -14755,7 +15001,7 @@
                   </a:txBody>
                   <a:tcPr anchor="ctr" marL="45720" marR="36576" marT="9144" marB="9144">
                     <a:solidFill>
-                      <a:srgbClr val="2CA9C7"/>
+                      <a:srgbClr val="8C8C8C"/>
                     </a:solidFill>
                   </a:tcPr>
                 </a:tc>
@@ -14768,7 +15014,7 @@
                       <a:r>
                         <a:rPr sz="560" b="1" i="0">
                           <a:solidFill>
-                            <a:srgbClr val="FFFFFF"/>
+                            <a:srgbClr val="3D3000"/>
                           </a:solidFill>
                           <a:latin typeface="Calibri"/>
                         </a:rPr>
@@ -14780,7 +15026,7 @@
                       <a:r>
                         <a:rPr sz="560" b="1" i="0">
                           <a:solidFill>
-                            <a:srgbClr val="FFFFFF"/>
+                            <a:srgbClr val="3D3000"/>
                           </a:solidFill>
                           <a:latin typeface="Calibri"/>
                         </a:rPr>
@@ -14790,7 +15036,7 @@
                   </a:txBody>
                   <a:tcPr anchor="ctr" marL="45720" marR="36576" marT="9144" marB="9144">
                     <a:solidFill>
-                      <a:srgbClr val="57A639"/>
+                      <a:srgbClr val="F5B400"/>
                     </a:solidFill>
                   </a:tcPr>
                 </a:tc>
@@ -14803,7 +15049,7 @@
                       <a:r>
                         <a:rPr sz="560" b="1" i="0">
                           <a:solidFill>
-                            <a:srgbClr val="FFFFFF"/>
+                            <a:srgbClr val="3D3000"/>
                           </a:solidFill>
                           <a:latin typeface="Calibri"/>
                         </a:rPr>
@@ -14815,7 +15061,7 @@
                       <a:r>
                         <a:rPr sz="560" b="1" i="0">
                           <a:solidFill>
-                            <a:srgbClr val="FFFFFF"/>
+                            <a:srgbClr val="3D3000"/>
                           </a:solidFill>
                           <a:latin typeface="Calibri"/>
                         </a:rPr>
@@ -14825,7 +15071,7 @@
                   </a:txBody>
                   <a:tcPr anchor="ctr" marL="45720" marR="36576" marT="9144" marB="9144">
                     <a:solidFill>
-                      <a:srgbClr val="57A639"/>
+                      <a:srgbClr val="F5B400"/>
                     </a:solidFill>
                   </a:tcPr>
                 </a:tc>
@@ -14838,7 +15084,7 @@
                       <a:r>
                         <a:rPr sz="560" b="1" i="0">
                           <a:solidFill>
-                            <a:srgbClr val="FFFFFF"/>
+                            <a:srgbClr val="3D3000"/>
                           </a:solidFill>
                           <a:latin typeface="Calibri"/>
                         </a:rPr>
@@ -14850,7 +15096,7 @@
                       <a:r>
                         <a:rPr sz="560" b="1" i="0">
                           <a:solidFill>
-                            <a:srgbClr val="FFFFFF"/>
+                            <a:srgbClr val="3D3000"/>
                           </a:solidFill>
                           <a:latin typeface="Calibri"/>
                         </a:rPr>
@@ -14860,7 +15106,7 @@
                   </a:txBody>
                   <a:tcPr anchor="ctr" marL="45720" marR="36576" marT="9144" marB="9144">
                     <a:solidFill>
-                      <a:srgbClr val="57A639"/>
+                      <a:srgbClr val="F5B400"/>
                     </a:solidFill>
                   </a:tcPr>
                 </a:tc>
@@ -14873,7 +15119,7 @@
                       <a:r>
                         <a:rPr sz="560" b="1" i="0">
                           <a:solidFill>
-                            <a:srgbClr val="FFFFFF"/>
+                            <a:srgbClr val="3D3000"/>
                           </a:solidFill>
                           <a:latin typeface="Calibri"/>
                         </a:rPr>
@@ -14885,7 +15131,7 @@
                       <a:r>
                         <a:rPr sz="560" b="1" i="0">
                           <a:solidFill>
-                            <a:srgbClr val="FFFFFF"/>
+                            <a:srgbClr val="3D3000"/>
                           </a:solidFill>
                           <a:latin typeface="Calibri"/>
                         </a:rPr>
@@ -14895,7 +15141,7 @@
                   </a:txBody>
                   <a:tcPr anchor="ctr" marL="45720" marR="36576" marT="9144" marB="9144">
                     <a:solidFill>
-                      <a:srgbClr val="57A639"/>
+                      <a:srgbClr val="F5B400"/>
                     </a:solidFill>
                   </a:tcPr>
                 </a:tc>
@@ -14908,7 +15154,7 @@
                       <a:r>
                         <a:rPr sz="560" b="1" i="0">
                           <a:solidFill>
-                            <a:srgbClr val="FFFFFF"/>
+                            <a:srgbClr val="3D3000"/>
                           </a:solidFill>
                           <a:latin typeface="Calibri"/>
                         </a:rPr>
@@ -14920,7 +15166,7 @@
                       <a:r>
                         <a:rPr sz="560" b="1" i="0">
                           <a:solidFill>
-                            <a:srgbClr val="FFFFFF"/>
+                            <a:srgbClr val="3D3000"/>
                           </a:solidFill>
                           <a:latin typeface="Calibri"/>
                         </a:rPr>
@@ -14930,7 +15176,7 @@
                   </a:txBody>
                   <a:tcPr anchor="ctr" marL="45720" marR="36576" marT="9144" marB="9144">
                     <a:solidFill>
-                      <a:srgbClr val="57A639"/>
+                      <a:srgbClr val="F5B400"/>
                     </a:solidFill>
                   </a:tcPr>
                 </a:tc>
@@ -14943,7 +15189,7 @@
                       <a:r>
                         <a:rPr sz="560" b="1" i="0">
                           <a:solidFill>
-                            <a:srgbClr val="FFFFFF"/>
+                            <a:srgbClr val="3D3000"/>
                           </a:solidFill>
                           <a:latin typeface="Calibri"/>
                         </a:rPr>
@@ -14955,7 +15201,7 @@
                       <a:r>
                         <a:rPr sz="560" b="1" i="0">
                           <a:solidFill>
-                            <a:srgbClr val="FFFFFF"/>
+                            <a:srgbClr val="3D3000"/>
                           </a:solidFill>
                           <a:latin typeface="Calibri"/>
                         </a:rPr>
@@ -14965,7 +15211,7 @@
                   </a:txBody>
                   <a:tcPr anchor="ctr" marL="45720" marR="36576" marT="9144" marB="9144">
                     <a:solidFill>
-                      <a:srgbClr val="57A639"/>
+                      <a:srgbClr val="F5B400"/>
                     </a:solidFill>
                   </a:tcPr>
                 </a:tc>
@@ -14978,7 +15224,7 @@
                       <a:r>
                         <a:rPr sz="560" b="1" i="0">
                           <a:solidFill>
-                            <a:srgbClr val="FFFFFF"/>
+                            <a:srgbClr val="3D3000"/>
                           </a:solidFill>
                           <a:latin typeface="Calibri"/>
                         </a:rPr>
@@ -14990,7 +15236,7 @@
                       <a:r>
                         <a:rPr sz="560" b="1" i="0">
                           <a:solidFill>
-                            <a:srgbClr val="FFFFFF"/>
+                            <a:srgbClr val="3D3000"/>
                           </a:solidFill>
                           <a:latin typeface="Calibri"/>
                         </a:rPr>
@@ -15000,7 +15246,7 @@
                   </a:txBody>
                   <a:tcPr anchor="ctr" marL="45720" marR="36576" marT="9144" marB="9144">
                     <a:solidFill>
-                      <a:srgbClr val="57A639"/>
+                      <a:srgbClr val="F5B400"/>
                     </a:solidFill>
                   </a:tcPr>
                 </a:tc>
@@ -15013,7 +15259,7 @@
                       <a:r>
                         <a:rPr sz="560" b="1" i="0">
                           <a:solidFill>
-                            <a:srgbClr val="FFFFFF"/>
+                            <a:srgbClr val="3D3000"/>
                           </a:solidFill>
                           <a:latin typeface="Calibri"/>
                         </a:rPr>
@@ -15025,7 +15271,7 @@
                       <a:r>
                         <a:rPr sz="560" b="1" i="0">
                           <a:solidFill>
-                            <a:srgbClr val="FFFFFF"/>
+                            <a:srgbClr val="3D3000"/>
                           </a:solidFill>
                           <a:latin typeface="Calibri"/>
                         </a:rPr>
@@ -15035,7 +15281,7 @@
                   </a:txBody>
                   <a:tcPr anchor="ctr" marL="45720" marR="36576" marT="9144" marB="9144">
                     <a:solidFill>
-                      <a:srgbClr val="57A639"/>
+                      <a:srgbClr val="F5B400"/>
                     </a:solidFill>
                   </a:tcPr>
                 </a:tc>
@@ -15048,7 +15294,7 @@
                       <a:r>
                         <a:rPr sz="560" b="1" i="0">
                           <a:solidFill>
-                            <a:srgbClr val="FFFFFF"/>
+                            <a:srgbClr val="3D3000"/>
                           </a:solidFill>
                           <a:latin typeface="Calibri"/>
                         </a:rPr>
@@ -15060,7 +15306,7 @@
                       <a:r>
                         <a:rPr sz="560" b="1" i="0">
                           <a:solidFill>
-                            <a:srgbClr val="FFFFFF"/>
+                            <a:srgbClr val="3D3000"/>
                           </a:solidFill>
                           <a:latin typeface="Calibri"/>
                         </a:rPr>
@@ -15070,7 +15316,7 @@
                   </a:txBody>
                   <a:tcPr anchor="ctr" marL="45720" marR="36576" marT="9144" marB="9144">
                     <a:solidFill>
-                      <a:srgbClr val="57A639"/>
+                      <a:srgbClr val="F5B400"/>
                     </a:solidFill>
                   </a:tcPr>
                 </a:tc>
@@ -15083,7 +15329,7 @@
                       <a:r>
                         <a:rPr sz="560" b="1" i="0">
                           <a:solidFill>
-                            <a:srgbClr val="FFFFFF"/>
+                            <a:srgbClr val="3D3000"/>
                           </a:solidFill>
                           <a:latin typeface="Calibri"/>
                         </a:rPr>
@@ -15095,7 +15341,7 @@
                       <a:r>
                         <a:rPr sz="560" b="1" i="0">
                           <a:solidFill>
-                            <a:srgbClr val="FFFFFF"/>
+                            <a:srgbClr val="3D3000"/>
                           </a:solidFill>
                           <a:latin typeface="Calibri"/>
                         </a:rPr>
@@ -15105,7 +15351,7 @@
                   </a:txBody>
                   <a:tcPr anchor="ctr" marL="45720" marR="36576" marT="9144" marB="9144">
                     <a:solidFill>
-                      <a:srgbClr val="57A639"/>
+                      <a:srgbClr val="F5B400"/>
                     </a:solidFill>
                   </a:tcPr>
                 </a:tc>
@@ -15118,7 +15364,7 @@
                       <a:r>
                         <a:rPr sz="560" b="1" i="0">
                           <a:solidFill>
-                            <a:srgbClr val="FFFFFF"/>
+                            <a:srgbClr val="3D3000"/>
                           </a:solidFill>
                           <a:latin typeface="Calibri"/>
                         </a:rPr>
@@ -15130,7 +15376,7 @@
                       <a:r>
                         <a:rPr sz="560" b="1" i="0">
                           <a:solidFill>
-                            <a:srgbClr val="FFFFFF"/>
+                            <a:srgbClr val="3D3000"/>
                           </a:solidFill>
                           <a:latin typeface="Calibri"/>
                         </a:rPr>
@@ -15140,12 +15386,12 @@
                   </a:txBody>
                   <a:tcPr anchor="ctr" marL="45720" marR="36576" marT="9144" marB="9144">
                     <a:solidFill>
-                      <a:srgbClr val="57A639"/>
+                      <a:srgbClr val="F5B400"/>
                     </a:solidFill>
                   </a:tcPr>
                 </a:tc>
               </a:tr>
-              <a:tr h="266319">
+              <a:tr h="246888">
                 <a:tc>
                   <a:txBody>
                     <a:bodyPr wrap="square"/>
@@ -15155,7 +15401,7 @@
                       <a:r>
                         <a:rPr sz="560" b="1" i="0">
                           <a:solidFill>
-                            <a:srgbClr val="1F3864"/>
+                            <a:srgbClr val="262626"/>
                           </a:solidFill>
                           <a:latin typeface="Calibri"/>
                         </a:rPr>
@@ -15165,7 +15411,7 @@
                   </a:txBody>
                   <a:tcPr anchor="ctr" marL="45720" marR="36576" marT="9144" marB="9144">
                     <a:solidFill>
-                      <a:srgbClr val="D9E2F3"/>
+                      <a:srgbClr val="FBEFCB"/>
                     </a:solidFill>
                   </a:tcPr>
                 </a:tc>
@@ -15515,7 +15761,7 @@
                   </a:tcPr>
                 </a:tc>
               </a:tr>
-              <a:tr h="266319">
+              <a:tr h="246888">
                 <a:tc>
                   <a:txBody>
                     <a:bodyPr wrap="square"/>
@@ -15525,7 +15771,7 @@
                       <a:r>
                         <a:rPr sz="560" b="1" i="0">
                           <a:solidFill>
-                            <a:srgbClr val="1F3864"/>
+                            <a:srgbClr val="262626"/>
                           </a:solidFill>
                           <a:latin typeface="Calibri"/>
                         </a:rPr>
@@ -15535,7 +15781,7 @@
                   </a:txBody>
                   <a:tcPr anchor="ctr" marL="45720" marR="36576" marT="9144" marB="9144">
                     <a:solidFill>
-                      <a:srgbClr val="D9E2F3"/>
+                      <a:srgbClr val="FBEFCB"/>
                     </a:solidFill>
                   </a:tcPr>
                 </a:tc>
@@ -15885,7 +16131,7 @@
                   </a:tcPr>
                 </a:tc>
               </a:tr>
-              <a:tr h="266319">
+              <a:tr h="246888">
                 <a:tc>
                   <a:txBody>
                     <a:bodyPr wrap="square"/>
@@ -15895,7 +16141,7 @@
                       <a:r>
                         <a:rPr sz="560" b="1" i="0">
                           <a:solidFill>
-                            <a:srgbClr val="1F3864"/>
+                            <a:srgbClr val="262626"/>
                           </a:solidFill>
                           <a:latin typeface="Calibri"/>
                         </a:rPr>
@@ -15905,7 +16151,7 @@
                   </a:txBody>
                   <a:tcPr anchor="ctr" marL="45720" marR="36576" marT="9144" marB="9144">
                     <a:solidFill>
-                      <a:srgbClr val="D9E2F3"/>
+                      <a:srgbClr val="FBEFCB"/>
                     </a:solidFill>
                   </a:tcPr>
                 </a:tc>
@@ -16255,7 +16501,7 @@
                   </a:tcPr>
                 </a:tc>
               </a:tr>
-              <a:tr h="266319">
+              <a:tr h="246888">
                 <a:tc>
                   <a:txBody>
                     <a:bodyPr wrap="square"/>
@@ -16265,7 +16511,7 @@
                       <a:r>
                         <a:rPr sz="560" b="1" i="0">
                           <a:solidFill>
-                            <a:srgbClr val="1F3864"/>
+                            <a:srgbClr val="262626"/>
                           </a:solidFill>
                           <a:latin typeface="Calibri"/>
                         </a:rPr>
@@ -16275,7 +16521,7 @@
                   </a:txBody>
                   <a:tcPr anchor="ctr" marL="45720" marR="36576" marT="9144" marB="9144">
                     <a:solidFill>
-                      <a:srgbClr val="D9E2F3"/>
+                      <a:srgbClr val="FBEFCB"/>
                     </a:solidFill>
                   </a:tcPr>
                 </a:tc>
@@ -16625,7 +16871,7 @@
                   </a:tcPr>
                 </a:tc>
               </a:tr>
-              <a:tr h="266319">
+              <a:tr h="246888">
                 <a:tc>
                   <a:txBody>
                     <a:bodyPr wrap="square"/>
@@ -16635,7 +16881,7 @@
                       <a:r>
                         <a:rPr sz="560" b="1" i="0">
                           <a:solidFill>
-                            <a:srgbClr val="1F3864"/>
+                            <a:srgbClr val="262626"/>
                           </a:solidFill>
                           <a:latin typeface="Calibri"/>
                         </a:rPr>
@@ -16645,7 +16891,7 @@
                   </a:txBody>
                   <a:tcPr anchor="ctr" marL="45720" marR="36576" marT="9144" marB="9144">
                     <a:solidFill>
-                      <a:srgbClr val="D9E2F3"/>
+                      <a:srgbClr val="FBEFCB"/>
                     </a:solidFill>
                   </a:tcPr>
                 </a:tc>
@@ -17007,7 +17253,7 @@
                   </a:tcPr>
                 </a:tc>
               </a:tr>
-              <a:tr h="266319">
+              <a:tr h="246888">
                 <a:tc>
                   <a:txBody>
                     <a:bodyPr wrap="square"/>
@@ -17017,7 +17263,7 @@
                       <a:r>
                         <a:rPr sz="560" b="1" i="0">
                           <a:solidFill>
-                            <a:srgbClr val="1F3864"/>
+                            <a:srgbClr val="262626"/>
                           </a:solidFill>
                           <a:latin typeface="Calibri"/>
                         </a:rPr>
@@ -17027,7 +17273,7 @@
                   </a:txBody>
                   <a:tcPr anchor="ctr" marL="45720" marR="36576" marT="9144" marB="9144">
                     <a:solidFill>
-                      <a:srgbClr val="D9E2F3"/>
+                      <a:srgbClr val="FBEFCB"/>
                     </a:solidFill>
                   </a:tcPr>
                 </a:tc>
@@ -17557,7 +17803,7 @@
                   </a:tcPr>
                 </a:tc>
               </a:tr>
-              <a:tr h="266319">
+              <a:tr h="246888">
                 <a:tc>
                   <a:txBody>
                     <a:bodyPr wrap="square"/>
@@ -17567,7 +17813,7 @@
                       <a:r>
                         <a:rPr sz="560" b="1" i="0">
                           <a:solidFill>
-                            <a:srgbClr val="1F3864"/>
+                            <a:srgbClr val="262626"/>
                           </a:solidFill>
                           <a:latin typeface="Calibri"/>
                         </a:rPr>
@@ -17577,7 +17823,7 @@
                   </a:txBody>
                   <a:tcPr anchor="ctr" marL="45720" marR="36576" marT="9144" marB="9144">
                     <a:solidFill>
-                      <a:srgbClr val="D9E2F3"/>
+                      <a:srgbClr val="FBEFCB"/>
                     </a:solidFill>
                   </a:tcPr>
                 </a:tc>
@@ -17927,7 +18173,7 @@
                   </a:tcPr>
                 </a:tc>
               </a:tr>
-              <a:tr h="266319">
+              <a:tr h="246888">
                 <a:tc>
                   <a:txBody>
                     <a:bodyPr wrap="square"/>
@@ -17937,7 +18183,7 @@
                       <a:r>
                         <a:rPr sz="560" b="1" i="0">
                           <a:solidFill>
-                            <a:srgbClr val="1F3864"/>
+                            <a:srgbClr val="262626"/>
                           </a:solidFill>
                           <a:latin typeface="Calibri"/>
                         </a:rPr>
@@ -17947,7 +18193,7 @@
                   </a:txBody>
                   <a:tcPr anchor="ctr" marL="45720" marR="36576" marT="9144" marB="9144">
                     <a:solidFill>
-                      <a:srgbClr val="D9E2F3"/>
+                      <a:srgbClr val="FBEFCB"/>
                     </a:solidFill>
                   </a:tcPr>
                 </a:tc>
@@ -18401,36 +18647,45 @@
       </p:sp>
       <p:sp>
         <p:nvSpPr>
-          <p:cNvPr id="3" name="TextBox 2"/>
-          <p:cNvSpPr txBox="1"/>
+          <p:cNvPr id="3" name="Rectangle 2"/>
+          <p:cNvSpPr/>
           <p:nvPr/>
         </p:nvSpPr>
         <p:spPr>
           <a:xfrm>
-            <a:off x="5486400" y="182880"/>
-            <a:ext cx="3291840" cy="228600"/>
+            <a:off x="384048" y="128016"/>
+            <a:ext cx="1325880" cy="201168"/>
           </a:xfrm>
           <a:prstGeom prst="rect">
             <a:avLst/>
           </a:prstGeom>
-          <a:noFill/>
+          <a:solidFill>
+            <a:srgbClr val="F5B400"/>
+          </a:solidFill>
+          <a:ln>
+            <a:noFill/>
+          </a:ln>
+          <a:effectLst/>
         </p:spPr>
+        <p:style>
+          <a:lnRef idx="1">
+            <a:schemeClr val="accent1"/>
+          </a:lnRef>
+          <a:fillRef idx="3">
+            <a:schemeClr val="accent1"/>
+          </a:fillRef>
+          <a:effectRef idx="2">
+            <a:schemeClr val="accent1"/>
+          </a:effectRef>
+          <a:fontRef idx="minor">
+            <a:schemeClr val="lt1"/>
+          </a:fontRef>
+        </p:style>
         <p:txBody>
-          <a:bodyPr wrap="square" anchor="t" lIns="0" rIns="0" tIns="0" bIns="0">
-            <a:spAutoFit/>
-          </a:bodyPr>
+          <a:bodyPr rtlCol="0" anchor="ctr"/>
           <a:lstStyle/>
           <a:p>
-            <a:pPr algn="r"/>
-            <a:r>
-              <a:rPr sz="750" b="1" i="0">
-                <a:solidFill>
-                  <a:srgbClr val="595959"/>
-                </a:solidFill>
-                <a:latin typeface="Calibri"/>
-              </a:rPr>
-              <a:t>2300 N STREET, NW  |  ES OPINION OF VALUE  |  JUN-26</a:t>
-            </a:r>
+            <a:pPr algn="ctr"/>
           </a:p>
         </p:txBody>
       </p:sp>
@@ -18442,8 +18697,8 @@
         </p:nvSpPr>
         <p:spPr>
           <a:xfrm>
-            <a:off x="384048" y="384048"/>
-            <a:ext cx="8229600" cy="502920"/>
+            <a:off x="365760" y="274320"/>
+            <a:ext cx="8229600" cy="685800"/>
           </a:xfrm>
           <a:prstGeom prst="rect">
             <a:avLst/>
@@ -18458,55 +18713,20 @@
           <a:p>
             <a:pPr algn="l"/>
             <a:r>
-              <a:rPr sz="2700" b="1" i="0">
+              <a:rPr sz="3200" b="0" i="0">
                 <a:solidFill>
-                  <a:srgbClr val="1F3864"/>
+                  <a:srgbClr val="262626"/>
                 </a:solidFill>
-                <a:latin typeface="Calibri"/>
+                <a:latin typeface="Calibri Light"/>
               </a:rPr>
-              <a:t>Washington, DC Recent Data Points</a:t>
-            </a:r>
-          </a:p>
-        </p:txBody>
-      </p:sp>
-      <p:sp>
-        <p:nvSpPr>
-          <p:cNvPr id="5" name="TextBox 4"/>
-          <p:cNvSpPr txBox="1"/>
-          <p:nvPr/>
-        </p:nvSpPr>
-        <p:spPr>
-          <a:xfrm>
-            <a:off x="402336" y="896112"/>
-            <a:ext cx="8229600" cy="365760"/>
-          </a:xfrm>
-          <a:prstGeom prst="rect">
-            <a:avLst/>
-          </a:prstGeom>
-          <a:noFill/>
-        </p:spPr>
-        <p:txBody>
-          <a:bodyPr wrap="square" anchor="t" lIns="0" rIns="0" tIns="0" bIns="0">
-            <a:spAutoFit/>
-          </a:bodyPr>
-          <a:lstStyle/>
-          <a:p>
-            <a:pPr algn="l"/>
-            <a:r>
-              <a:rPr sz="1700" b="1" i="0">
-                <a:solidFill>
-                  <a:srgbClr val="2CA9C7"/>
-                </a:solidFill>
-                <a:latin typeface="Calibri"/>
-              </a:rPr>
-              <a:t>Select ES Office Financings</a:t>
+              <a:t>Recent Data Points</a:t>
             </a:r>
           </a:p>
         </p:txBody>
       </p:sp>
       <p:cxnSp>
         <p:nvCxnSpPr>
-          <p:cNvPr id="6" name="Connector 5"/>
+          <p:cNvPr id="5" name="Connector 4"/>
           <p:cNvCxnSpPr/>
           <p:nvPr/>
         </p:nvCxnSpPr>
@@ -18541,7 +18761,7 @@
       </p:cxnSp>
       <p:sp>
         <p:nvSpPr>
-          <p:cNvPr id="7" name="TextBox 6"/>
+          <p:cNvPr id="6" name="TextBox 5"/>
           <p:cNvSpPr txBox="1"/>
           <p:nvPr/>
         </p:nvSpPr>
@@ -18576,7 +18796,7 @@
       </p:sp>
       <p:sp>
         <p:nvSpPr>
-          <p:cNvPr id="8" name="TextBox 7"/>
+          <p:cNvPr id="7" name="TextBox 6"/>
           <p:cNvSpPr txBox="1"/>
           <p:nvPr/>
         </p:nvSpPr>
@@ -18609,17 +18829,166 @@
           </a:p>
         </p:txBody>
       </p:sp>
+      <p:sp>
+        <p:nvSpPr>
+          <p:cNvPr id="8" name="Rectangle 7"/>
+          <p:cNvSpPr/>
+          <p:nvPr/>
+        </p:nvSpPr>
+        <p:spPr>
+          <a:xfrm>
+            <a:off x="384048" y="914400"/>
+            <a:ext cx="8375904" cy="566928"/>
+          </a:xfrm>
+          <a:prstGeom prst="rect">
+            <a:avLst/>
+          </a:prstGeom>
+          <a:solidFill>
+            <a:srgbClr val="F5B400"/>
+          </a:solidFill>
+          <a:ln>
+            <a:noFill/>
+          </a:ln>
+          <a:effectLst/>
+        </p:spPr>
+        <p:style>
+          <a:lnRef idx="1">
+            <a:schemeClr val="accent1"/>
+          </a:lnRef>
+          <a:fillRef idx="3">
+            <a:schemeClr val="accent1"/>
+          </a:fillRef>
+          <a:effectRef idx="2">
+            <a:schemeClr val="accent1"/>
+          </a:effectRef>
+          <a:fontRef idx="minor">
+            <a:schemeClr val="lt1"/>
+          </a:fontRef>
+        </p:style>
+        <p:txBody>
+          <a:bodyPr rtlCol="0" anchor="ctr"/>
+          <a:lstStyle/>
+          <a:p>
+            <a:pPr algn="ctr"/>
+          </a:p>
+        </p:txBody>
+      </p:sp>
+      <p:sp>
+        <p:nvSpPr>
+          <p:cNvPr id="9" name="TextBox 8"/>
+          <p:cNvSpPr txBox="1"/>
+          <p:nvPr/>
+        </p:nvSpPr>
+        <p:spPr>
+          <a:xfrm>
+            <a:off x="548640" y="978408"/>
+            <a:ext cx="5943600" cy="274320"/>
+          </a:xfrm>
+          <a:prstGeom prst="rect">
+            <a:avLst/>
+          </a:prstGeom>
+          <a:noFill/>
+        </p:spPr>
+        <p:txBody>
+          <a:bodyPr wrap="square" anchor="t" lIns="0" rIns="0" tIns="0" bIns="0">
+            <a:spAutoFit/>
+          </a:bodyPr>
+          <a:lstStyle/>
+          <a:p>
+            <a:pPr algn="l"/>
+            <a:r>
+              <a:rPr sz="1250" b="1" i="0">
+                <a:solidFill>
+                  <a:srgbClr val="3D3000"/>
+                </a:solidFill>
+                <a:latin typeface="Calibri"/>
+              </a:rPr>
+              <a:t>WASHINGTON, DC METRO — DEBT DATA POINTS</a:t>
+            </a:r>
+          </a:p>
+        </p:txBody>
+      </p:sp>
+      <p:sp>
+        <p:nvSpPr>
+          <p:cNvPr id="10" name="TextBox 9"/>
+          <p:cNvSpPr txBox="1"/>
+          <p:nvPr/>
+        </p:nvSpPr>
+        <p:spPr>
+          <a:xfrm>
+            <a:off x="548640" y="1216152"/>
+            <a:ext cx="5943600" cy="228600"/>
+          </a:xfrm>
+          <a:prstGeom prst="rect">
+            <a:avLst/>
+          </a:prstGeom>
+          <a:noFill/>
+        </p:spPr>
+        <p:txBody>
+          <a:bodyPr wrap="square" anchor="t" lIns="0" rIns="0" tIns="0" bIns="0">
+            <a:spAutoFit/>
+          </a:bodyPr>
+          <a:lstStyle/>
+          <a:p>
+            <a:pPr algn="l"/>
+            <a:r>
+              <a:rPr sz="1000" b="0" i="1">
+                <a:solidFill>
+                  <a:srgbClr val="3D3000"/>
+                </a:solidFill>
+                <a:latin typeface="Calibri"/>
+              </a:rPr>
+              <a:t>Recent Eastdil Secured Office Financings</a:t>
+            </a:r>
+          </a:p>
+        </p:txBody>
+      </p:sp>
+      <p:sp>
+        <p:nvSpPr>
+          <p:cNvPr id="11" name="TextBox 10"/>
+          <p:cNvSpPr txBox="1"/>
+          <p:nvPr/>
+        </p:nvSpPr>
+        <p:spPr>
+          <a:xfrm>
+            <a:off x="6766560" y="1005840"/>
+            <a:ext cx="1828800" cy="365760"/>
+          </a:xfrm>
+          <a:prstGeom prst="rect">
+            <a:avLst/>
+          </a:prstGeom>
+          <a:noFill/>
+        </p:spPr>
+        <p:txBody>
+          <a:bodyPr wrap="square" anchor="t" lIns="0" rIns="0" tIns="0" bIns="0">
+            <a:spAutoFit/>
+          </a:bodyPr>
+          <a:lstStyle/>
+          <a:p>
+            <a:pPr algn="r"/>
+            <a:r>
+              <a:rPr sz="2400" b="1" i="0">
+                <a:solidFill>
+                  <a:srgbClr val="3D3000"/>
+                </a:solidFill>
+                <a:latin typeface="Georgia"/>
+              </a:rPr>
+              <a:t>Lincoln</a:t>
+            </a:r>
+          </a:p>
+        </p:txBody>
+      </p:sp>
       <p:graphicFrame>
         <p:nvGraphicFramePr>
-          <p:cNvPr id="9" name="Table 8"/>
+          <p:cNvPr id="12" name="Table 11"/>
           <p:cNvGraphicFramePr>
             <a:graphicFrameLocks noGrp="1"/>
           </p:cNvGraphicFramePr>
           <p:nvPr/>
         </p:nvGraphicFramePr>
         <p:xfrm>
-          <a:off x="384048" y="1325880"/>
-          <a:ext cx="8375904" cy="3355840"/>
+          <a:off x="384048" y="1572768"/>
+          <a:ext cx="8375904" cy="3108952"/>
         </p:xfrm>
         <a:graphic>
           <a:graphicData uri="http://schemas.openxmlformats.org/drawingml/2006/table">
@@ -18638,7 +19007,7 @@
                 <a:gridCol w="900684"/>
                 <a:gridCol w="900684"/>
               </a:tblGrid>
-              <a:tr h="402336">
+              <a:tr h="365760">
                 <a:tc>
                   <a:txBody>
                     <a:bodyPr wrap="square"/>
@@ -18646,7 +19015,7 @@
                     <a:p>
                       <a:pPr algn="l"/>
                       <a:r>
-                        <a:rPr sz="620" b="0" i="0">
+                        <a:rPr sz="600" b="0" i="0">
                           <a:solidFill>
                             <a:srgbClr val="FFFFFF"/>
                           </a:solidFill>
@@ -18669,7 +19038,7 @@
                     <a:p>
                       <a:pPr algn="ctr"/>
                       <a:r>
-                        <a:rPr sz="680" b="1" i="0">
+                        <a:rPr sz="660" b="1" i="0">
                           <a:solidFill>
                             <a:srgbClr val="FFFFFF"/>
                           </a:solidFill>
@@ -18681,7 +19050,7 @@
                     <a:p>
                       <a:pPr algn="ctr"/>
                       <a:r>
-                        <a:rPr sz="680" b="1" i="0">
+                        <a:rPr sz="660" b="1" i="0">
                           <a:solidFill>
                             <a:srgbClr val="FFFFFF"/>
                           </a:solidFill>
@@ -18693,18 +19062,18 @@
                   </a:txBody>
                   <a:tcPr anchor="ctr" marL="45720" marR="36576" marT="9144" marB="9144">
                     <a:solidFill>
-                      <a:srgbClr val="1F3864"/>
-                    </a:solidFill>
-                  </a:tcPr>
-                </a:tc>
-                <a:tc>
-                  <a:txBody>
-                    <a:bodyPr wrap="square"/>
-                    <a:lstStyle/>
-                    <a:p>
-                      <a:pPr algn="ctr"/>
-                      <a:r>
-                        <a:rPr sz="680" b="1" i="0">
+                      <a:srgbClr val="222222"/>
+                    </a:solidFill>
+                  </a:tcPr>
+                </a:tc>
+                <a:tc>
+                  <a:txBody>
+                    <a:bodyPr wrap="square"/>
+                    <a:lstStyle/>
+                    <a:p>
+                      <a:pPr algn="ctr"/>
+                      <a:r>
+                        <a:rPr sz="660" b="1" i="0">
                           <a:solidFill>
                             <a:srgbClr val="FFFFFF"/>
                           </a:solidFill>
@@ -18716,7 +19085,7 @@
                     <a:p>
                       <a:pPr algn="ctr"/>
                       <a:r>
-                        <a:rPr sz="680" b="1" i="0">
+                        <a:rPr sz="660" b="1" i="0">
                           <a:solidFill>
                             <a:srgbClr val="FFFFFF"/>
                           </a:solidFill>
@@ -18728,18 +19097,18 @@
                   </a:txBody>
                   <a:tcPr anchor="ctr" marL="45720" marR="36576" marT="9144" marB="9144">
                     <a:solidFill>
-                      <a:srgbClr val="1F3864"/>
-                    </a:solidFill>
-                  </a:tcPr>
-                </a:tc>
-                <a:tc>
-                  <a:txBody>
-                    <a:bodyPr wrap="square"/>
-                    <a:lstStyle/>
-                    <a:p>
-                      <a:pPr algn="ctr"/>
-                      <a:r>
-                        <a:rPr sz="680" b="1" i="0">
+                      <a:srgbClr val="222222"/>
+                    </a:solidFill>
+                  </a:tcPr>
+                </a:tc>
+                <a:tc>
+                  <a:txBody>
+                    <a:bodyPr wrap="square"/>
+                    <a:lstStyle/>
+                    <a:p>
+                      <a:pPr algn="ctr"/>
+                      <a:r>
+                        <a:rPr sz="660" b="1" i="0">
                           <a:solidFill>
                             <a:srgbClr val="FFFFFF"/>
                           </a:solidFill>
@@ -18751,7 +19120,7 @@
                     <a:p>
                       <a:pPr algn="ctr"/>
                       <a:r>
-                        <a:rPr sz="680" b="1" i="0">
+                        <a:rPr sz="660" b="1" i="0">
                           <a:solidFill>
                             <a:srgbClr val="FFFFFF"/>
                           </a:solidFill>
@@ -18763,18 +19132,18 @@
                   </a:txBody>
                   <a:tcPr anchor="ctr" marL="45720" marR="36576" marT="9144" marB="9144">
                     <a:solidFill>
-                      <a:srgbClr val="1F3864"/>
-                    </a:solidFill>
-                  </a:tcPr>
-                </a:tc>
-                <a:tc>
-                  <a:txBody>
-                    <a:bodyPr wrap="square"/>
-                    <a:lstStyle/>
-                    <a:p>
-                      <a:pPr algn="ctr"/>
-                      <a:r>
-                        <a:rPr sz="680" b="1" i="0">
+                      <a:srgbClr val="222222"/>
+                    </a:solidFill>
+                  </a:tcPr>
+                </a:tc>
+                <a:tc>
+                  <a:txBody>
+                    <a:bodyPr wrap="square"/>
+                    <a:lstStyle/>
+                    <a:p>
+                      <a:pPr algn="ctr"/>
+                      <a:r>
+                        <a:rPr sz="660" b="1" i="0">
                           <a:solidFill>
                             <a:srgbClr val="FFFFFF"/>
                           </a:solidFill>
@@ -18786,18 +19155,18 @@
                   </a:txBody>
                   <a:tcPr anchor="ctr" marL="45720" marR="36576" marT="9144" marB="9144">
                     <a:solidFill>
-                      <a:srgbClr val="1F3864"/>
-                    </a:solidFill>
-                  </a:tcPr>
-                </a:tc>
-                <a:tc>
-                  <a:txBody>
-                    <a:bodyPr wrap="square"/>
-                    <a:lstStyle/>
-                    <a:p>
-                      <a:pPr algn="ctr"/>
-                      <a:r>
-                        <a:rPr sz="680" b="1" i="0">
+                      <a:srgbClr val="222222"/>
+                    </a:solidFill>
+                  </a:tcPr>
+                </a:tc>
+                <a:tc>
+                  <a:txBody>
+                    <a:bodyPr wrap="square"/>
+                    <a:lstStyle/>
+                    <a:p>
+                      <a:pPr algn="ctr"/>
+                      <a:r>
+                        <a:rPr sz="660" b="1" i="0">
                           <a:solidFill>
                             <a:srgbClr val="FFFFFF"/>
                           </a:solidFill>
@@ -18809,7 +19178,7 @@
                     <a:p>
                       <a:pPr algn="ctr"/>
                       <a:r>
-                        <a:rPr sz="680" b="1" i="0">
+                        <a:rPr sz="660" b="1" i="0">
                           <a:solidFill>
                             <a:srgbClr val="FFFFFF"/>
                           </a:solidFill>
@@ -18821,18 +19190,18 @@
                   </a:txBody>
                   <a:tcPr anchor="ctr" marL="45720" marR="36576" marT="9144" marB="9144">
                     <a:solidFill>
-                      <a:srgbClr val="1F3864"/>
-                    </a:solidFill>
-                  </a:tcPr>
-                </a:tc>
-                <a:tc>
-                  <a:txBody>
-                    <a:bodyPr wrap="square"/>
-                    <a:lstStyle/>
-                    <a:p>
-                      <a:pPr algn="ctr"/>
-                      <a:r>
-                        <a:rPr sz="680" b="1" i="0">
+                      <a:srgbClr val="222222"/>
+                    </a:solidFill>
+                  </a:tcPr>
+                </a:tc>
+                <a:tc>
+                  <a:txBody>
+                    <a:bodyPr wrap="square"/>
+                    <a:lstStyle/>
+                    <a:p>
+                      <a:pPr algn="ctr"/>
+                      <a:r>
+                        <a:rPr sz="660" b="1" i="0">
                           <a:solidFill>
                             <a:srgbClr val="FFFFFF"/>
                           </a:solidFill>
@@ -18844,7 +19213,7 @@
                     <a:p>
                       <a:pPr algn="ctr"/>
                       <a:r>
-                        <a:rPr sz="680" b="1" i="0">
+                        <a:rPr sz="660" b="1" i="0">
                           <a:solidFill>
                             <a:srgbClr val="FFFFFF"/>
                           </a:solidFill>
@@ -18856,18 +19225,18 @@
                   </a:txBody>
                   <a:tcPr anchor="ctr" marL="45720" marR="36576" marT="9144" marB="9144">
                     <a:solidFill>
-                      <a:srgbClr val="1F3864"/>
-                    </a:solidFill>
-                  </a:tcPr>
-                </a:tc>
-                <a:tc>
-                  <a:txBody>
-                    <a:bodyPr wrap="square"/>
-                    <a:lstStyle/>
-                    <a:p>
-                      <a:pPr algn="ctr"/>
-                      <a:r>
-                        <a:rPr sz="680" b="1" i="0">
+                      <a:srgbClr val="222222"/>
+                    </a:solidFill>
+                  </a:tcPr>
+                </a:tc>
+                <a:tc>
+                  <a:txBody>
+                    <a:bodyPr wrap="square"/>
+                    <a:lstStyle/>
+                    <a:p>
+                      <a:pPr algn="ctr"/>
+                      <a:r>
+                        <a:rPr sz="660" b="1" i="0">
                           <a:solidFill>
                             <a:srgbClr val="FFFFFF"/>
                           </a:solidFill>
@@ -18879,18 +19248,18 @@
                   </a:txBody>
                   <a:tcPr anchor="ctr" marL="45720" marR="36576" marT="9144" marB="9144">
                     <a:solidFill>
-                      <a:srgbClr val="1F3864"/>
-                    </a:solidFill>
-                  </a:tcPr>
-                </a:tc>
-                <a:tc>
-                  <a:txBody>
-                    <a:bodyPr wrap="square"/>
-                    <a:lstStyle/>
-                    <a:p>
-                      <a:pPr algn="ctr"/>
-                      <a:r>
-                        <a:rPr sz="680" b="1" i="0">
+                      <a:srgbClr val="222222"/>
+                    </a:solidFill>
+                  </a:tcPr>
+                </a:tc>
+                <a:tc>
+                  <a:txBody>
+                    <a:bodyPr wrap="square"/>
+                    <a:lstStyle/>
+                    <a:p>
+                      <a:pPr algn="ctr"/>
+                      <a:r>
+                        <a:rPr sz="660" b="1" i="0">
                           <a:solidFill>
                             <a:srgbClr val="FFFFFF"/>
                           </a:solidFill>
@@ -18902,12 +19271,12 @@
                   </a:txBody>
                   <a:tcPr anchor="ctr" marL="45720" marR="36576" marT="9144" marB="9144">
                     <a:solidFill>
-                      <a:srgbClr val="1F3864"/>
+                      <a:srgbClr val="222222"/>
                     </a:solidFill>
                   </a:tcPr>
                 </a:tc>
               </a:tr>
-              <a:tr h="420624">
+              <a:tr h="365760">
                 <a:tc>
                   <a:txBody>
                     <a:bodyPr wrap="square"/>
@@ -18915,7 +19284,7 @@
                     <a:p>
                       <a:pPr algn="l"/>
                       <a:r>
-                        <a:rPr sz="620" b="0" i="0">
+                        <a:rPr sz="600" b="0" i="0">
                           <a:solidFill>
                             <a:srgbClr val="FFFFFF"/>
                           </a:solidFill>
@@ -19116,7 +19485,7 @@
                   </a:tcPr>
                 </a:tc>
               </a:tr>
-              <a:tr h="274320">
+              <a:tr h="256032">
                 <a:tc>
                   <a:txBody>
                     <a:bodyPr wrap="square"/>
@@ -19124,7 +19493,7 @@
                     <a:p>
                       <a:pPr algn="l"/>
                       <a:r>
-                        <a:rPr sz="620" b="0" i="0">
+                        <a:rPr sz="600" b="0" i="0">
                           <a:solidFill>
                             <a:srgbClr val="FFFFFF"/>
                           </a:solidFill>
@@ -19147,7 +19516,7 @@
                     <a:p>
                       <a:pPr algn="ctr"/>
                       <a:r>
-                        <a:rPr sz="620" b="1" i="0">
+                        <a:rPr sz="600" b="1" i="0">
                           <a:solidFill>
                             <a:srgbClr val="FFFFFF"/>
                           </a:solidFill>
@@ -19159,18 +19528,18 @@
                   </a:txBody>
                   <a:tcPr anchor="ctr" marL="45720" marR="36576" marT="9144" marB="9144">
                     <a:solidFill>
-                      <a:srgbClr val="2CA9C7"/>
-                    </a:solidFill>
-                  </a:tcPr>
-                </a:tc>
-                <a:tc>
-                  <a:txBody>
-                    <a:bodyPr wrap="square"/>
-                    <a:lstStyle/>
-                    <a:p>
-                      <a:pPr algn="ctr"/>
-                      <a:r>
-                        <a:rPr sz="620" b="1" i="0">
+                      <a:srgbClr val="8C8C8C"/>
+                    </a:solidFill>
+                  </a:tcPr>
+                </a:tc>
+                <a:tc>
+                  <a:txBody>
+                    <a:bodyPr wrap="square"/>
+                    <a:lstStyle/>
+                    <a:p>
+                      <a:pPr algn="ctr"/>
+                      <a:r>
+                        <a:rPr sz="600" b="1" i="0">
                           <a:solidFill>
                             <a:srgbClr val="FFFFFF"/>
                           </a:solidFill>
@@ -19182,18 +19551,18 @@
                   </a:txBody>
                   <a:tcPr anchor="ctr" marL="45720" marR="36576" marT="9144" marB="9144">
                     <a:solidFill>
-                      <a:srgbClr val="2CA9C7"/>
-                    </a:solidFill>
-                  </a:tcPr>
-                </a:tc>
-                <a:tc>
-                  <a:txBody>
-                    <a:bodyPr wrap="square"/>
-                    <a:lstStyle/>
-                    <a:p>
-                      <a:pPr algn="ctr"/>
-                      <a:r>
-                        <a:rPr sz="620" b="1" i="0">
+                      <a:srgbClr val="8C8C8C"/>
+                    </a:solidFill>
+                  </a:tcPr>
+                </a:tc>
+                <a:tc>
+                  <a:txBody>
+                    <a:bodyPr wrap="square"/>
+                    <a:lstStyle/>
+                    <a:p>
+                      <a:pPr algn="ctr"/>
+                      <a:r>
+                        <a:rPr sz="600" b="1" i="0">
                           <a:solidFill>
                             <a:srgbClr val="FFFFFF"/>
                           </a:solidFill>
@@ -19205,7 +19574,7 @@
                     <a:p>
                       <a:pPr algn="ctr"/>
                       <a:r>
-                        <a:rPr sz="620" b="1" i="0">
+                        <a:rPr sz="600" b="1" i="0">
                           <a:solidFill>
                             <a:srgbClr val="FFFFFF"/>
                           </a:solidFill>
@@ -19217,20 +19586,20 @@
                   </a:txBody>
                   <a:tcPr anchor="ctr" marL="45720" marR="36576" marT="9144" marB="9144">
                     <a:solidFill>
-                      <a:srgbClr val="2CA9C7"/>
-                    </a:solidFill>
-                  </a:tcPr>
-                </a:tc>
-                <a:tc>
-                  <a:txBody>
-                    <a:bodyPr wrap="square"/>
-                    <a:lstStyle/>
-                    <a:p>
-                      <a:pPr algn="ctr"/>
-                      <a:r>
-                        <a:rPr sz="620" b="1" i="0">
-                          <a:solidFill>
-                            <a:srgbClr val="FFFFFF"/>
+                      <a:srgbClr val="8C8C8C"/>
+                    </a:solidFill>
+                  </a:tcPr>
+                </a:tc>
+                <a:tc>
+                  <a:txBody>
+                    <a:bodyPr wrap="square"/>
+                    <a:lstStyle/>
+                    <a:p>
+                      <a:pPr algn="ctr"/>
+                      <a:r>
+                        <a:rPr sz="600" b="1" i="0">
+                          <a:solidFill>
+                            <a:srgbClr val="3D3000"/>
                           </a:solidFill>
                           <a:latin typeface="Calibri"/>
                         </a:rPr>
@@ -19240,9 +19609,9 @@
                     <a:p>
                       <a:pPr algn="ctr"/>
                       <a:r>
-                        <a:rPr sz="620" b="1" i="0">
-                          <a:solidFill>
-                            <a:srgbClr val="FFFFFF"/>
+                        <a:rPr sz="600" b="1" i="0">
+                          <a:solidFill>
+                            <a:srgbClr val="3D3000"/>
                           </a:solidFill>
                           <a:latin typeface="Calibri"/>
                         </a:rPr>
@@ -19252,20 +19621,20 @@
                   </a:txBody>
                   <a:tcPr anchor="ctr" marL="45720" marR="36576" marT="9144" marB="9144">
                     <a:solidFill>
-                      <a:srgbClr val="57A639"/>
-                    </a:solidFill>
-                  </a:tcPr>
-                </a:tc>
-                <a:tc>
-                  <a:txBody>
-                    <a:bodyPr wrap="square"/>
-                    <a:lstStyle/>
-                    <a:p>
-                      <a:pPr algn="ctr"/>
-                      <a:r>
-                        <a:rPr sz="620" b="1" i="0">
-                          <a:solidFill>
-                            <a:srgbClr val="FFFFFF"/>
+                      <a:srgbClr val="F5B400"/>
+                    </a:solidFill>
+                  </a:tcPr>
+                </a:tc>
+                <a:tc>
+                  <a:txBody>
+                    <a:bodyPr wrap="square"/>
+                    <a:lstStyle/>
+                    <a:p>
+                      <a:pPr algn="ctr"/>
+                      <a:r>
+                        <a:rPr sz="600" b="1" i="0">
+                          <a:solidFill>
+                            <a:srgbClr val="3D3000"/>
                           </a:solidFill>
                           <a:latin typeface="Calibri"/>
                         </a:rPr>
@@ -19275,9 +19644,9 @@
                     <a:p>
                       <a:pPr algn="ctr"/>
                       <a:r>
-                        <a:rPr sz="620" b="1" i="0">
-                          <a:solidFill>
-                            <a:srgbClr val="FFFFFF"/>
+                        <a:rPr sz="600" b="1" i="0">
+                          <a:solidFill>
+                            <a:srgbClr val="3D3000"/>
                           </a:solidFill>
                           <a:latin typeface="Calibri"/>
                         </a:rPr>
@@ -19287,20 +19656,20 @@
                   </a:txBody>
                   <a:tcPr anchor="ctr" marL="45720" marR="36576" marT="9144" marB="9144">
                     <a:solidFill>
-                      <a:srgbClr val="57A639"/>
-                    </a:solidFill>
-                  </a:tcPr>
-                </a:tc>
-                <a:tc>
-                  <a:txBody>
-                    <a:bodyPr wrap="square"/>
-                    <a:lstStyle/>
-                    <a:p>
-                      <a:pPr algn="ctr"/>
-                      <a:r>
-                        <a:rPr sz="620" b="1" i="0">
-                          <a:solidFill>
-                            <a:srgbClr val="FFFFFF"/>
+                      <a:srgbClr val="F5B400"/>
+                    </a:solidFill>
+                  </a:tcPr>
+                </a:tc>
+                <a:tc>
+                  <a:txBody>
+                    <a:bodyPr wrap="square"/>
+                    <a:lstStyle/>
+                    <a:p>
+                      <a:pPr algn="ctr"/>
+                      <a:r>
+                        <a:rPr sz="600" b="1" i="0">
+                          <a:solidFill>
+                            <a:srgbClr val="3D3000"/>
                           </a:solidFill>
                           <a:latin typeface="Calibri"/>
                         </a:rPr>
@@ -19310,9 +19679,9 @@
                     <a:p>
                       <a:pPr algn="ctr"/>
                       <a:r>
-                        <a:rPr sz="620" b="1" i="0">
-                          <a:solidFill>
-                            <a:srgbClr val="FFFFFF"/>
+                        <a:rPr sz="600" b="1" i="0">
+                          <a:solidFill>
+                            <a:srgbClr val="3D3000"/>
                           </a:solidFill>
                           <a:latin typeface="Calibri"/>
                         </a:rPr>
@@ -19322,20 +19691,20 @@
                   </a:txBody>
                   <a:tcPr anchor="ctr" marL="45720" marR="36576" marT="9144" marB="9144">
                     <a:solidFill>
-                      <a:srgbClr val="57A639"/>
-                    </a:solidFill>
-                  </a:tcPr>
-                </a:tc>
-                <a:tc>
-                  <a:txBody>
-                    <a:bodyPr wrap="square"/>
-                    <a:lstStyle/>
-                    <a:p>
-                      <a:pPr algn="ctr"/>
-                      <a:r>
-                        <a:rPr sz="620" b="1" i="0">
-                          <a:solidFill>
-                            <a:srgbClr val="FFFFFF"/>
+                      <a:srgbClr val="F5B400"/>
+                    </a:solidFill>
+                  </a:tcPr>
+                </a:tc>
+                <a:tc>
+                  <a:txBody>
+                    <a:bodyPr wrap="square"/>
+                    <a:lstStyle/>
+                    <a:p>
+                      <a:pPr algn="ctr"/>
+                      <a:r>
+                        <a:rPr sz="600" b="1" i="0">
+                          <a:solidFill>
+                            <a:srgbClr val="3D3000"/>
                           </a:solidFill>
                           <a:latin typeface="Calibri"/>
                         </a:rPr>
@@ -19345,9 +19714,9 @@
                     <a:p>
                       <a:pPr algn="ctr"/>
                       <a:r>
-                        <a:rPr sz="620" b="1" i="0">
-                          <a:solidFill>
-                            <a:srgbClr val="FFFFFF"/>
+                        <a:rPr sz="600" b="1" i="0">
+                          <a:solidFill>
+                            <a:srgbClr val="3D3000"/>
                           </a:solidFill>
                           <a:latin typeface="Calibri"/>
                         </a:rPr>
@@ -19357,20 +19726,20 @@
                   </a:txBody>
                   <a:tcPr anchor="ctr" marL="45720" marR="36576" marT="9144" marB="9144">
                     <a:solidFill>
-                      <a:srgbClr val="57A639"/>
-                    </a:solidFill>
-                  </a:tcPr>
-                </a:tc>
-                <a:tc>
-                  <a:txBody>
-                    <a:bodyPr wrap="square"/>
-                    <a:lstStyle/>
-                    <a:p>
-                      <a:pPr algn="ctr"/>
-                      <a:r>
-                        <a:rPr sz="620" b="1" i="0">
-                          <a:solidFill>
-                            <a:srgbClr val="FFFFFF"/>
+                      <a:srgbClr val="F5B400"/>
+                    </a:solidFill>
+                  </a:tcPr>
+                </a:tc>
+                <a:tc>
+                  <a:txBody>
+                    <a:bodyPr wrap="square"/>
+                    <a:lstStyle/>
+                    <a:p>
+                      <a:pPr algn="ctr"/>
+                      <a:r>
+                        <a:rPr sz="600" b="1" i="0">
+                          <a:solidFill>
+                            <a:srgbClr val="3D3000"/>
                           </a:solidFill>
                           <a:latin typeface="Calibri"/>
                         </a:rPr>
@@ -19380,9 +19749,9 @@
                     <a:p>
                       <a:pPr algn="ctr"/>
                       <a:r>
-                        <a:rPr sz="620" b="1" i="0">
-                          <a:solidFill>
-                            <a:srgbClr val="FFFFFF"/>
+                        <a:rPr sz="600" b="1" i="0">
+                          <a:solidFill>
+                            <a:srgbClr val="3D3000"/>
                           </a:solidFill>
                           <a:latin typeface="Calibri"/>
                         </a:rPr>
@@ -19392,12 +19761,12 @@
                   </a:txBody>
                   <a:tcPr anchor="ctr" marL="45720" marR="36576" marT="9144" marB="9144">
                     <a:solidFill>
-                      <a:srgbClr val="57A639"/>
+                      <a:srgbClr val="F5B400"/>
                     </a:solidFill>
                   </a:tcPr>
                 </a:tc>
               </a:tr>
-              <a:tr h="225856">
+              <a:tr h="212140">
                 <a:tc>
                   <a:txBody>
                     <a:bodyPr wrap="square"/>
@@ -19405,9 +19774,9 @@
                     <a:p>
                       <a:pPr algn="l"/>
                       <a:r>
-                        <a:rPr sz="620" b="1" i="0">
-                          <a:solidFill>
-                            <a:srgbClr val="1F3864"/>
+                        <a:rPr sz="600" b="1" i="0">
+                          <a:solidFill>
+                            <a:srgbClr val="262626"/>
                           </a:solidFill>
                           <a:latin typeface="Calibri"/>
                         </a:rPr>
@@ -19417,18 +19786,18 @@
                   </a:txBody>
                   <a:tcPr anchor="ctr" marL="45720" marR="36576" marT="9144" marB="9144">
                     <a:solidFill>
-                      <a:srgbClr val="D9E2F3"/>
-                    </a:solidFill>
-                  </a:tcPr>
-                </a:tc>
-                <a:tc>
-                  <a:txBody>
-                    <a:bodyPr wrap="square"/>
-                    <a:lstStyle/>
-                    <a:p>
-                      <a:pPr algn="ctr"/>
-                      <a:r>
-                        <a:rPr sz="620" b="0" i="0">
+                      <a:srgbClr val="FBEFCB"/>
+                    </a:solidFill>
+                  </a:tcPr>
+                </a:tc>
+                <a:tc>
+                  <a:txBody>
+                    <a:bodyPr wrap="square"/>
+                    <a:lstStyle/>
+                    <a:p>
+                      <a:pPr algn="ctr"/>
+                      <a:r>
+                        <a:rPr sz="600" b="0" i="0">
                           <a:solidFill>
                             <a:srgbClr val="262626"/>
                           </a:solidFill>
@@ -19451,7 +19820,7 @@
                     <a:p>
                       <a:pPr algn="ctr"/>
                       <a:r>
-                        <a:rPr sz="620" b="0" i="0">
+                        <a:rPr sz="600" b="0" i="0">
                           <a:solidFill>
                             <a:srgbClr val="262626"/>
                           </a:solidFill>
@@ -19474,7 +19843,7 @@
                     <a:p>
                       <a:pPr algn="ctr"/>
                       <a:r>
-                        <a:rPr sz="620" b="0" i="0">
+                        <a:rPr sz="600" b="0" i="0">
                           <a:solidFill>
                             <a:srgbClr val="262626"/>
                           </a:solidFill>
@@ -19486,7 +19855,7 @@
                     <a:p>
                       <a:pPr algn="ctr"/>
                       <a:r>
-                        <a:rPr sz="620" b="0" i="0">
+                        <a:rPr sz="600" b="0" i="0">
                           <a:solidFill>
                             <a:srgbClr val="262626"/>
                           </a:solidFill>
@@ -19509,7 +19878,7 @@
                     <a:p>
                       <a:pPr algn="ctr"/>
                       <a:r>
-                        <a:rPr sz="620" b="0" i="0">
+                        <a:rPr sz="600" b="0" i="0">
                           <a:solidFill>
                             <a:srgbClr val="262626"/>
                           </a:solidFill>
@@ -19532,7 +19901,7 @@
                     <a:p>
                       <a:pPr algn="ctr"/>
                       <a:r>
-                        <a:rPr sz="620" b="0" i="0">
+                        <a:rPr sz="600" b="0" i="0">
                           <a:solidFill>
                             <a:srgbClr val="262626"/>
                           </a:solidFill>
@@ -19555,7 +19924,7 @@
                     <a:p>
                       <a:pPr algn="ctr"/>
                       <a:r>
-                        <a:rPr sz="620" b="0" i="0">
+                        <a:rPr sz="600" b="0" i="0">
                           <a:solidFill>
                             <a:srgbClr val="262626"/>
                           </a:solidFill>
@@ -19578,7 +19947,7 @@
                     <a:p>
                       <a:pPr algn="ctr"/>
                       <a:r>
-                        <a:rPr sz="620" b="0" i="0">
+                        <a:rPr sz="600" b="0" i="0">
                           <a:solidFill>
                             <a:srgbClr val="262626"/>
                           </a:solidFill>
@@ -19601,7 +19970,7 @@
                     <a:p>
                       <a:pPr algn="ctr"/>
                       <a:r>
-                        <a:rPr sz="620" b="0" i="0">
+                        <a:rPr sz="600" b="0" i="0">
                           <a:solidFill>
                             <a:srgbClr val="262626"/>
                           </a:solidFill>
@@ -19613,7 +19982,7 @@
                     <a:p>
                       <a:pPr algn="ctr"/>
                       <a:r>
-                        <a:rPr sz="620" b="0" i="0">
+                        <a:rPr sz="600" b="0" i="0">
                           <a:solidFill>
                             <a:srgbClr val="262626"/>
                           </a:solidFill>
@@ -19630,7 +19999,7 @@
                   </a:tcPr>
                 </a:tc>
               </a:tr>
-              <a:tr h="225856">
+              <a:tr h="212140">
                 <a:tc>
                   <a:txBody>
                     <a:bodyPr wrap="square"/>
@@ -19638,9 +20007,9 @@
                     <a:p>
                       <a:pPr algn="l"/>
                       <a:r>
-                        <a:rPr sz="620" b="1" i="0">
-                          <a:solidFill>
-                            <a:srgbClr val="1F3864"/>
+                        <a:rPr sz="600" b="1" i="0">
+                          <a:solidFill>
+                            <a:srgbClr val="262626"/>
                           </a:solidFill>
                           <a:latin typeface="Calibri"/>
                         </a:rPr>
@@ -19650,18 +20019,18 @@
                   </a:txBody>
                   <a:tcPr anchor="ctr" marL="45720" marR="36576" marT="9144" marB="9144">
                     <a:solidFill>
-                      <a:srgbClr val="D9E2F3"/>
-                    </a:solidFill>
-                  </a:tcPr>
-                </a:tc>
-                <a:tc>
-                  <a:txBody>
-                    <a:bodyPr wrap="square"/>
-                    <a:lstStyle/>
-                    <a:p>
-                      <a:pPr algn="ctr"/>
-                      <a:r>
-                        <a:rPr sz="620" b="0" i="0">
+                      <a:srgbClr val="FBEFCB"/>
+                    </a:solidFill>
+                  </a:tcPr>
+                </a:tc>
+                <a:tc>
+                  <a:txBody>
+                    <a:bodyPr wrap="square"/>
+                    <a:lstStyle/>
+                    <a:p>
+                      <a:pPr algn="ctr"/>
+                      <a:r>
+                        <a:rPr sz="600" b="0" i="0">
                           <a:solidFill>
                             <a:srgbClr val="262626"/>
                           </a:solidFill>
@@ -19684,7 +20053,7 @@
                     <a:p>
                       <a:pPr algn="ctr"/>
                       <a:r>
-                        <a:rPr sz="620" b="0" i="0">
+                        <a:rPr sz="600" b="0" i="0">
                           <a:solidFill>
                             <a:srgbClr val="262626"/>
                           </a:solidFill>
@@ -19707,7 +20076,7 @@
                     <a:p>
                       <a:pPr algn="ctr"/>
                       <a:r>
-                        <a:rPr sz="620" b="0" i="0">
+                        <a:rPr sz="600" b="0" i="0">
                           <a:solidFill>
                             <a:srgbClr val="262626"/>
                           </a:solidFill>
@@ -19730,7 +20099,7 @@
                     <a:p>
                       <a:pPr algn="ctr"/>
                       <a:r>
-                        <a:rPr sz="620" b="0" i="0">
+                        <a:rPr sz="600" b="0" i="0">
                           <a:solidFill>
                             <a:srgbClr val="262626"/>
                           </a:solidFill>
@@ -19753,7 +20122,7 @@
                     <a:p>
                       <a:pPr algn="ctr"/>
                       <a:r>
-                        <a:rPr sz="620" b="0" i="0">
+                        <a:rPr sz="600" b="0" i="0">
                           <a:solidFill>
                             <a:srgbClr val="262626"/>
                           </a:solidFill>
@@ -19776,7 +20145,7 @@
                     <a:p>
                       <a:pPr algn="ctr"/>
                       <a:r>
-                        <a:rPr sz="620" b="0" i="0">
+                        <a:rPr sz="600" b="0" i="0">
                           <a:solidFill>
                             <a:srgbClr val="262626"/>
                           </a:solidFill>
@@ -19799,7 +20168,7 @@
                     <a:p>
                       <a:pPr algn="ctr"/>
                       <a:r>
-                        <a:rPr sz="620" b="0" i="0">
+                        <a:rPr sz="600" b="0" i="0">
                           <a:solidFill>
                             <a:srgbClr val="262626"/>
                           </a:solidFill>
@@ -19822,7 +20191,7 @@
                     <a:p>
                       <a:pPr algn="ctr"/>
                       <a:r>
-                        <a:rPr sz="620" b="0" i="0">
+                        <a:rPr sz="600" b="0" i="0">
                           <a:solidFill>
                             <a:srgbClr val="262626"/>
                           </a:solidFill>
@@ -19839,7 +20208,7 @@
                   </a:tcPr>
                 </a:tc>
               </a:tr>
-              <a:tr h="225856">
+              <a:tr h="212140">
                 <a:tc>
                   <a:txBody>
                     <a:bodyPr wrap="square"/>
@@ -19847,9 +20216,9 @@
                     <a:p>
                       <a:pPr algn="l"/>
                       <a:r>
-                        <a:rPr sz="620" b="1" i="0">
-                          <a:solidFill>
-                            <a:srgbClr val="1F3864"/>
+                        <a:rPr sz="600" b="1" i="0">
+                          <a:solidFill>
+                            <a:srgbClr val="262626"/>
                           </a:solidFill>
                           <a:latin typeface="Calibri"/>
                         </a:rPr>
@@ -19859,18 +20228,18 @@
                   </a:txBody>
                   <a:tcPr anchor="ctr" marL="45720" marR="36576" marT="9144" marB="9144">
                     <a:solidFill>
-                      <a:srgbClr val="D9E2F3"/>
-                    </a:solidFill>
-                  </a:tcPr>
-                </a:tc>
-                <a:tc>
-                  <a:txBody>
-                    <a:bodyPr wrap="square"/>
-                    <a:lstStyle/>
-                    <a:p>
-                      <a:pPr algn="ctr"/>
-                      <a:r>
-                        <a:rPr sz="620" b="0" i="0">
+                      <a:srgbClr val="FBEFCB"/>
+                    </a:solidFill>
+                  </a:tcPr>
+                </a:tc>
+                <a:tc>
+                  <a:txBody>
+                    <a:bodyPr wrap="square"/>
+                    <a:lstStyle/>
+                    <a:p>
+                      <a:pPr algn="ctr"/>
+                      <a:r>
+                        <a:rPr sz="600" b="0" i="0">
                           <a:solidFill>
                             <a:srgbClr val="262626"/>
                           </a:solidFill>
@@ -19893,7 +20262,7 @@
                     <a:p>
                       <a:pPr algn="ctr"/>
                       <a:r>
-                        <a:rPr sz="620" b="0" i="0">
+                        <a:rPr sz="600" b="0" i="0">
                           <a:solidFill>
                             <a:srgbClr val="262626"/>
                           </a:solidFill>
@@ -19916,7 +20285,7 @@
                     <a:p>
                       <a:pPr algn="ctr"/>
                       <a:r>
-                        <a:rPr sz="620" b="0" i="0">
+                        <a:rPr sz="600" b="0" i="0">
                           <a:solidFill>
                             <a:srgbClr val="262626"/>
                           </a:solidFill>
@@ -19939,7 +20308,7 @@
                     <a:p>
                       <a:pPr algn="ctr"/>
                       <a:r>
-                        <a:rPr sz="620" b="0" i="0">
+                        <a:rPr sz="600" b="0" i="0">
                           <a:solidFill>
                             <a:srgbClr val="262626"/>
                           </a:solidFill>
@@ -19962,7 +20331,7 @@
                     <a:p>
                       <a:pPr algn="ctr"/>
                       <a:r>
-                        <a:rPr sz="620" b="0" i="0">
+                        <a:rPr sz="600" b="0" i="0">
                           <a:solidFill>
                             <a:srgbClr val="262626"/>
                           </a:solidFill>
@@ -19985,7 +20354,7 @@
                     <a:p>
                       <a:pPr algn="ctr"/>
                       <a:r>
-                        <a:rPr sz="620" b="0" i="0">
+                        <a:rPr sz="600" b="0" i="0">
                           <a:solidFill>
                             <a:srgbClr val="262626"/>
                           </a:solidFill>
@@ -20008,7 +20377,7 @@
                     <a:p>
                       <a:pPr algn="ctr"/>
                       <a:r>
-                        <a:rPr sz="620" b="0" i="0">
+                        <a:rPr sz="600" b="0" i="0">
                           <a:solidFill>
                             <a:srgbClr val="262626"/>
                           </a:solidFill>
@@ -20031,7 +20400,7 @@
                     <a:p>
                       <a:pPr algn="ctr"/>
                       <a:r>
-                        <a:rPr sz="620" b="0" i="0">
+                        <a:rPr sz="600" b="0" i="0">
                           <a:solidFill>
                             <a:srgbClr val="262626"/>
                           </a:solidFill>
@@ -20048,7 +20417,7 @@
                   </a:tcPr>
                 </a:tc>
               </a:tr>
-              <a:tr h="225856">
+              <a:tr h="212140">
                 <a:tc>
                   <a:txBody>
                     <a:bodyPr wrap="square"/>
@@ -20056,9 +20425,9 @@
                     <a:p>
                       <a:pPr algn="l"/>
                       <a:r>
-                        <a:rPr sz="620" b="1" i="0">
-                          <a:solidFill>
-                            <a:srgbClr val="1F3864"/>
+                        <a:rPr sz="600" b="1" i="0">
+                          <a:solidFill>
+                            <a:srgbClr val="262626"/>
                           </a:solidFill>
                           <a:latin typeface="Calibri"/>
                         </a:rPr>
@@ -20068,18 +20437,18 @@
                   </a:txBody>
                   <a:tcPr anchor="ctr" marL="45720" marR="36576" marT="9144" marB="9144">
                     <a:solidFill>
-                      <a:srgbClr val="D9E2F3"/>
-                    </a:solidFill>
-                  </a:tcPr>
-                </a:tc>
-                <a:tc>
-                  <a:txBody>
-                    <a:bodyPr wrap="square"/>
-                    <a:lstStyle/>
-                    <a:p>
-                      <a:pPr algn="ctr"/>
-                      <a:r>
-                        <a:rPr sz="620" b="0" i="0">
+                      <a:srgbClr val="FBEFCB"/>
+                    </a:solidFill>
+                  </a:tcPr>
+                </a:tc>
+                <a:tc>
+                  <a:txBody>
+                    <a:bodyPr wrap="square"/>
+                    <a:lstStyle/>
+                    <a:p>
+                      <a:pPr algn="ctr"/>
+                      <a:r>
+                        <a:rPr sz="600" b="0" i="0">
                           <a:solidFill>
                             <a:srgbClr val="262626"/>
                           </a:solidFill>
@@ -20102,7 +20471,7 @@
                     <a:p>
                       <a:pPr algn="ctr"/>
                       <a:r>
-                        <a:rPr sz="620" b="0" i="0">
+                        <a:rPr sz="600" b="0" i="0">
                           <a:solidFill>
                             <a:srgbClr val="262626"/>
                           </a:solidFill>
@@ -20125,7 +20494,7 @@
                     <a:p>
                       <a:pPr algn="ctr"/>
                       <a:r>
-                        <a:rPr sz="620" b="0" i="0">
+                        <a:rPr sz="600" b="0" i="0">
                           <a:solidFill>
                             <a:srgbClr val="262626"/>
                           </a:solidFill>
@@ -20148,7 +20517,7 @@
                     <a:p>
                       <a:pPr algn="ctr"/>
                       <a:r>
-                        <a:rPr sz="620" b="0" i="0">
+                        <a:rPr sz="600" b="0" i="0">
                           <a:solidFill>
                             <a:srgbClr val="262626"/>
                           </a:solidFill>
@@ -20171,7 +20540,7 @@
                     <a:p>
                       <a:pPr algn="ctr"/>
                       <a:r>
-                        <a:rPr sz="620" b="0" i="0">
+                        <a:rPr sz="600" b="0" i="0">
                           <a:solidFill>
                             <a:srgbClr val="262626"/>
                           </a:solidFill>
@@ -20194,7 +20563,7 @@
                     <a:p>
                       <a:pPr algn="ctr"/>
                       <a:r>
-                        <a:rPr sz="620" b="0" i="0">
+                        <a:rPr sz="600" b="0" i="0">
                           <a:solidFill>
                             <a:srgbClr val="262626"/>
                           </a:solidFill>
@@ -20217,7 +20586,7 @@
                     <a:p>
                       <a:pPr algn="ctr"/>
                       <a:r>
-                        <a:rPr sz="620" b="0" i="0">
+                        <a:rPr sz="600" b="0" i="0">
                           <a:solidFill>
                             <a:srgbClr val="262626"/>
                           </a:solidFill>
@@ -20240,7 +20609,7 @@
                     <a:p>
                       <a:pPr algn="ctr"/>
                       <a:r>
-                        <a:rPr sz="620" b="0" i="0">
+                        <a:rPr sz="600" b="0" i="0">
                           <a:solidFill>
                             <a:srgbClr val="262626"/>
                           </a:solidFill>
@@ -20257,7 +20626,7 @@
                   </a:tcPr>
                 </a:tc>
               </a:tr>
-              <a:tr h="225856">
+              <a:tr h="212140">
                 <a:tc>
                   <a:txBody>
                     <a:bodyPr wrap="square"/>
@@ -20265,9 +20634,9 @@
                     <a:p>
                       <a:pPr algn="l"/>
                       <a:r>
-                        <a:rPr sz="620" b="1" i="0">
-                          <a:solidFill>
-                            <a:srgbClr val="1F3864"/>
+                        <a:rPr sz="600" b="1" i="0">
+                          <a:solidFill>
+                            <a:srgbClr val="262626"/>
                           </a:solidFill>
                           <a:latin typeface="Calibri"/>
                         </a:rPr>
@@ -20277,18 +20646,18 @@
                   </a:txBody>
                   <a:tcPr anchor="ctr" marL="45720" marR="36576" marT="9144" marB="9144">
                     <a:solidFill>
-                      <a:srgbClr val="D9E2F3"/>
-                    </a:solidFill>
-                  </a:tcPr>
-                </a:tc>
-                <a:tc>
-                  <a:txBody>
-                    <a:bodyPr wrap="square"/>
-                    <a:lstStyle/>
-                    <a:p>
-                      <a:pPr algn="ctr"/>
-                      <a:r>
-                        <a:rPr sz="620" b="0" i="0">
+                      <a:srgbClr val="FBEFCB"/>
+                    </a:solidFill>
+                  </a:tcPr>
+                </a:tc>
+                <a:tc>
+                  <a:txBody>
+                    <a:bodyPr wrap="square"/>
+                    <a:lstStyle/>
+                    <a:p>
+                      <a:pPr algn="ctr"/>
+                      <a:r>
+                        <a:rPr sz="600" b="0" i="0">
                           <a:solidFill>
                             <a:srgbClr val="262626"/>
                           </a:solidFill>
@@ -20311,7 +20680,7 @@
                     <a:p>
                       <a:pPr algn="ctr"/>
                       <a:r>
-                        <a:rPr sz="620" b="0" i="0">
+                        <a:rPr sz="600" b="0" i="0">
                           <a:solidFill>
                             <a:srgbClr val="262626"/>
                           </a:solidFill>
@@ -20334,7 +20703,7 @@
                     <a:p>
                       <a:pPr algn="ctr"/>
                       <a:r>
-                        <a:rPr sz="620" b="0" i="0">
+                        <a:rPr sz="600" b="0" i="0">
                           <a:solidFill>
                             <a:srgbClr val="262626"/>
                           </a:solidFill>
@@ -20357,7 +20726,7 @@
                     <a:p>
                       <a:pPr algn="ctr"/>
                       <a:r>
-                        <a:rPr sz="620" b="0" i="0">
+                        <a:rPr sz="600" b="0" i="0">
                           <a:solidFill>
                             <a:srgbClr val="262626"/>
                           </a:solidFill>
@@ -20380,7 +20749,7 @@
                     <a:p>
                       <a:pPr algn="ctr"/>
                       <a:r>
-                        <a:rPr sz="620" b="0" i="0">
+                        <a:rPr sz="600" b="0" i="0">
                           <a:solidFill>
                             <a:srgbClr val="262626"/>
                           </a:solidFill>
@@ -20403,7 +20772,7 @@
                     <a:p>
                       <a:pPr algn="ctr"/>
                       <a:r>
-                        <a:rPr sz="620" b="0" i="0">
+                        <a:rPr sz="600" b="0" i="0">
                           <a:solidFill>
                             <a:srgbClr val="262626"/>
                           </a:solidFill>
@@ -20426,7 +20795,7 @@
                     <a:p>
                       <a:pPr algn="ctr"/>
                       <a:r>
-                        <a:rPr sz="620" b="0" i="0">
+                        <a:rPr sz="600" b="0" i="0">
                           <a:solidFill>
                             <a:srgbClr val="262626"/>
                           </a:solidFill>
@@ -20449,7 +20818,7 @@
                     <a:p>
                       <a:pPr algn="ctr"/>
                       <a:r>
-                        <a:rPr sz="620" b="0" i="0">
+                        <a:rPr sz="600" b="0" i="0">
                           <a:solidFill>
                             <a:srgbClr val="262626"/>
                           </a:solidFill>
@@ -20466,7 +20835,7 @@
                   </a:tcPr>
                 </a:tc>
               </a:tr>
-              <a:tr h="225856">
+              <a:tr h="212140">
                 <a:tc>
                   <a:txBody>
                     <a:bodyPr wrap="square"/>
@@ -20474,9 +20843,9 @@
                     <a:p>
                       <a:pPr algn="l"/>
                       <a:r>
-                        <a:rPr sz="620" b="1" i="0">
-                          <a:solidFill>
-                            <a:srgbClr val="1F3864"/>
+                        <a:rPr sz="600" b="1" i="0">
+                          <a:solidFill>
+                            <a:srgbClr val="262626"/>
                           </a:solidFill>
                           <a:latin typeface="Calibri"/>
                         </a:rPr>
@@ -20486,18 +20855,18 @@
                   </a:txBody>
                   <a:tcPr anchor="ctr" marL="45720" marR="36576" marT="9144" marB="9144">
                     <a:solidFill>
-                      <a:srgbClr val="D9E2F3"/>
-                    </a:solidFill>
-                  </a:tcPr>
-                </a:tc>
-                <a:tc>
-                  <a:txBody>
-                    <a:bodyPr wrap="square"/>
-                    <a:lstStyle/>
-                    <a:p>
-                      <a:pPr algn="ctr"/>
-                      <a:r>
-                        <a:rPr sz="620" b="0" i="0">
+                      <a:srgbClr val="FBEFCB"/>
+                    </a:solidFill>
+                  </a:tcPr>
+                </a:tc>
+                <a:tc>
+                  <a:txBody>
+                    <a:bodyPr wrap="square"/>
+                    <a:lstStyle/>
+                    <a:p>
+                      <a:pPr algn="ctr"/>
+                      <a:r>
+                        <a:rPr sz="600" b="0" i="0">
                           <a:solidFill>
                             <a:srgbClr val="262626"/>
                           </a:solidFill>
@@ -20520,7 +20889,7 @@
                     <a:p>
                       <a:pPr algn="ctr"/>
                       <a:r>
-                        <a:rPr sz="620" b="0" i="0">
+                        <a:rPr sz="600" b="0" i="0">
                           <a:solidFill>
                             <a:srgbClr val="262626"/>
                           </a:solidFill>
@@ -20543,7 +20912,7 @@
                     <a:p>
                       <a:pPr algn="ctr"/>
                       <a:r>
-                        <a:rPr sz="620" b="0" i="0">
+                        <a:rPr sz="600" b="0" i="0">
                           <a:solidFill>
                             <a:srgbClr val="262626"/>
                           </a:solidFill>
@@ -20566,7 +20935,7 @@
                     <a:p>
                       <a:pPr algn="ctr"/>
                       <a:r>
-                        <a:rPr sz="620" b="0" i="0">
+                        <a:rPr sz="600" b="0" i="0">
                           <a:solidFill>
                             <a:srgbClr val="262626"/>
                           </a:solidFill>
@@ -20589,7 +20958,7 @@
                     <a:p>
                       <a:pPr algn="ctr"/>
                       <a:r>
-                        <a:rPr sz="620" b="0" i="0">
+                        <a:rPr sz="600" b="0" i="0">
                           <a:solidFill>
                             <a:srgbClr val="262626"/>
                           </a:solidFill>
@@ -20612,7 +20981,7 @@
                     <a:p>
                       <a:pPr algn="ctr"/>
                       <a:r>
-                        <a:rPr sz="620" b="0" i="0">
+                        <a:rPr sz="600" b="0" i="0">
                           <a:solidFill>
                             <a:srgbClr val="262626"/>
                           </a:solidFill>
@@ -20635,7 +21004,7 @@
                     <a:p>
                       <a:pPr algn="ctr"/>
                       <a:r>
-                        <a:rPr sz="620" b="0" i="0">
+                        <a:rPr sz="600" b="0" i="0">
                           <a:solidFill>
                             <a:srgbClr val="262626"/>
                           </a:solidFill>
@@ -20658,7 +21027,7 @@
                     <a:p>
                       <a:pPr algn="ctr"/>
                       <a:r>
-                        <a:rPr sz="620" b="0" i="0">
+                        <a:rPr sz="600" b="0" i="0">
                           <a:solidFill>
                             <a:srgbClr val="262626"/>
                           </a:solidFill>
@@ -20675,7 +21044,7 @@
                   </a:tcPr>
                 </a:tc>
               </a:tr>
-              <a:tr h="225856">
+              <a:tr h="212140">
                 <a:tc>
                   <a:txBody>
                     <a:bodyPr wrap="square"/>
@@ -20683,9 +21052,9 @@
                     <a:p>
                       <a:pPr algn="l"/>
                       <a:r>
-                        <a:rPr sz="620" b="1" i="0">
-                          <a:solidFill>
-                            <a:srgbClr val="1F3864"/>
+                        <a:rPr sz="600" b="1" i="0">
+                          <a:solidFill>
+                            <a:srgbClr val="262626"/>
                           </a:solidFill>
                           <a:latin typeface="Calibri"/>
                         </a:rPr>
@@ -20695,18 +21064,18 @@
                   </a:txBody>
                   <a:tcPr anchor="ctr" marL="45720" marR="36576" marT="9144" marB="9144">
                     <a:solidFill>
-                      <a:srgbClr val="D9E2F3"/>
-                    </a:solidFill>
-                  </a:tcPr>
-                </a:tc>
-                <a:tc>
-                  <a:txBody>
-                    <a:bodyPr wrap="square"/>
-                    <a:lstStyle/>
-                    <a:p>
-                      <a:pPr algn="ctr"/>
-                      <a:r>
-                        <a:rPr sz="620" b="0" i="0">
+                      <a:srgbClr val="FBEFCB"/>
+                    </a:solidFill>
+                  </a:tcPr>
+                </a:tc>
+                <a:tc>
+                  <a:txBody>
+                    <a:bodyPr wrap="square"/>
+                    <a:lstStyle/>
+                    <a:p>
+                      <a:pPr algn="ctr"/>
+                      <a:r>
+                        <a:rPr sz="600" b="0" i="0">
                           <a:solidFill>
                             <a:srgbClr val="262626"/>
                           </a:solidFill>
@@ -20729,7 +21098,7 @@
                     <a:p>
                       <a:pPr algn="ctr"/>
                       <a:r>
-                        <a:rPr sz="620" b="0" i="0">
+                        <a:rPr sz="600" b="0" i="0">
                           <a:solidFill>
                             <a:srgbClr val="262626"/>
                           </a:solidFill>
@@ -20752,7 +21121,7 @@
                     <a:p>
                       <a:pPr algn="ctr"/>
                       <a:r>
-                        <a:rPr sz="620" b="0" i="0">
+                        <a:rPr sz="600" b="0" i="0">
                           <a:solidFill>
                             <a:srgbClr val="262626"/>
                           </a:solidFill>
@@ -20775,7 +21144,7 @@
                     <a:p>
                       <a:pPr algn="ctr"/>
                       <a:r>
-                        <a:rPr sz="620" b="0" i="0">
+                        <a:rPr sz="600" b="0" i="0">
                           <a:solidFill>
                             <a:srgbClr val="262626"/>
                           </a:solidFill>
@@ -20787,7 +21156,7 @@
                     <a:p>
                       <a:pPr algn="ctr"/>
                       <a:r>
-                        <a:rPr sz="620" b="0" i="0">
+                        <a:rPr sz="600" b="0" i="0">
                           <a:solidFill>
                             <a:srgbClr val="262626"/>
                           </a:solidFill>
@@ -20810,7 +21179,7 @@
                     <a:p>
                       <a:pPr algn="ctr"/>
                       <a:r>
-                        <a:rPr sz="620" b="0" i="0">
+                        <a:rPr sz="600" b="0" i="0">
                           <a:solidFill>
                             <a:srgbClr val="262626"/>
                           </a:solidFill>
@@ -20822,7 +21191,7 @@
                     <a:p>
                       <a:pPr algn="ctr"/>
                       <a:r>
-                        <a:rPr sz="620" b="0" i="0">
+                        <a:rPr sz="600" b="0" i="0">
                           <a:solidFill>
                             <a:srgbClr val="262626"/>
                           </a:solidFill>
@@ -20845,7 +21214,7 @@
                     <a:p>
                       <a:pPr algn="ctr"/>
                       <a:r>
-                        <a:rPr sz="620" b="0" i="0">
+                        <a:rPr sz="600" b="0" i="0">
                           <a:solidFill>
                             <a:srgbClr val="262626"/>
                           </a:solidFill>
@@ -20868,7 +21237,7 @@
                     <a:p>
                       <a:pPr algn="ctr"/>
                       <a:r>
-                        <a:rPr sz="620" b="0" i="0">
+                        <a:rPr sz="600" b="0" i="0">
                           <a:solidFill>
                             <a:srgbClr val="262626"/>
                           </a:solidFill>
@@ -20880,7 +21249,7 @@
                     <a:p>
                       <a:pPr algn="ctr"/>
                       <a:r>
-                        <a:rPr sz="620" b="0" i="0">
+                        <a:rPr sz="600" b="0" i="0">
                           <a:solidFill>
                             <a:srgbClr val="262626"/>
                           </a:solidFill>
@@ -20903,7 +21272,7 @@
                     <a:p>
                       <a:pPr algn="ctr"/>
                       <a:r>
-                        <a:rPr sz="620" b="0" i="0">
+                        <a:rPr sz="600" b="0" i="0">
                           <a:solidFill>
                             <a:srgbClr val="262626"/>
                           </a:solidFill>
@@ -20920,7 +21289,7 @@
                   </a:tcPr>
                 </a:tc>
               </a:tr>
-              <a:tr h="225856">
+              <a:tr h="212140">
                 <a:tc>
                   <a:txBody>
                     <a:bodyPr wrap="square"/>
@@ -20928,9 +21297,9 @@
                     <a:p>
                       <a:pPr algn="l"/>
                       <a:r>
-                        <a:rPr sz="620" b="1" i="0">
-                          <a:solidFill>
-                            <a:srgbClr val="1F3864"/>
+                        <a:rPr sz="600" b="1" i="0">
+                          <a:solidFill>
+                            <a:srgbClr val="262626"/>
                           </a:solidFill>
                           <a:latin typeface="Calibri"/>
                         </a:rPr>
@@ -20940,18 +21309,18 @@
                   </a:txBody>
                   <a:tcPr anchor="ctr" marL="45720" marR="36576" marT="9144" marB="9144">
                     <a:solidFill>
-                      <a:srgbClr val="D9E2F3"/>
-                    </a:solidFill>
-                  </a:tcPr>
-                </a:tc>
-                <a:tc>
-                  <a:txBody>
-                    <a:bodyPr wrap="square"/>
-                    <a:lstStyle/>
-                    <a:p>
-                      <a:pPr algn="ctr"/>
-                      <a:r>
-                        <a:rPr sz="620" b="0" i="0">
+                      <a:srgbClr val="FBEFCB"/>
+                    </a:solidFill>
+                  </a:tcPr>
+                </a:tc>
+                <a:tc>
+                  <a:txBody>
+                    <a:bodyPr wrap="square"/>
+                    <a:lstStyle/>
+                    <a:p>
+                      <a:pPr algn="ctr"/>
+                      <a:r>
+                        <a:rPr sz="600" b="0" i="0">
                           <a:solidFill>
                             <a:srgbClr val="262626"/>
                           </a:solidFill>
@@ -20974,7 +21343,7 @@
                     <a:p>
                       <a:pPr algn="ctr"/>
                       <a:r>
-                        <a:rPr sz="620" b="0" i="0">
+                        <a:rPr sz="600" b="0" i="0">
                           <a:solidFill>
                             <a:srgbClr val="262626"/>
                           </a:solidFill>
@@ -20997,7 +21366,7 @@
                     <a:p>
                       <a:pPr algn="ctr"/>
                       <a:r>
-                        <a:rPr sz="620" b="0" i="0">
+                        <a:rPr sz="600" b="0" i="0">
                           <a:solidFill>
                             <a:srgbClr val="262626"/>
                           </a:solidFill>
@@ -21020,7 +21389,7 @@
                     <a:p>
                       <a:pPr algn="ctr"/>
                       <a:r>
-                        <a:rPr sz="620" b="0" i="0">
+                        <a:rPr sz="600" b="0" i="0">
                           <a:solidFill>
                             <a:srgbClr val="262626"/>
                           </a:solidFill>
@@ -21043,7 +21412,7 @@
                     <a:p>
                       <a:pPr algn="ctr"/>
                       <a:r>
-                        <a:rPr sz="620" b="0" i="0">
+                        <a:rPr sz="600" b="0" i="0">
                           <a:solidFill>
                             <a:srgbClr val="262626"/>
                           </a:solidFill>
@@ -21066,7 +21435,7 @@
                     <a:p>
                       <a:pPr algn="ctr"/>
                       <a:r>
-                        <a:rPr sz="620" b="0" i="0">
+                        <a:rPr sz="600" b="0" i="0">
                           <a:solidFill>
                             <a:srgbClr val="262626"/>
                           </a:solidFill>
@@ -21089,7 +21458,7 @@
                     <a:p>
                       <a:pPr algn="ctr"/>
                       <a:r>
-                        <a:rPr sz="620" b="0" i="0">
+                        <a:rPr sz="600" b="0" i="0">
                           <a:solidFill>
                             <a:srgbClr val="262626"/>
                           </a:solidFill>
@@ -21112,7 +21481,7 @@
                     <a:p>
                       <a:pPr algn="ctr"/>
                       <a:r>
-                        <a:rPr sz="620" b="0" i="0">
+                        <a:rPr sz="600" b="0" i="0">
                           <a:solidFill>
                             <a:srgbClr val="262626"/>
                           </a:solidFill>
@@ -21129,7 +21498,7 @@
                   </a:tcPr>
                 </a:tc>
               </a:tr>
-              <a:tr h="225856">
+              <a:tr h="212140">
                 <a:tc>
                   <a:txBody>
                     <a:bodyPr wrap="square"/>
@@ -21137,9 +21506,9 @@
                     <a:p>
                       <a:pPr algn="l"/>
                       <a:r>
-                        <a:rPr sz="620" b="1" i="0">
-                          <a:solidFill>
-                            <a:srgbClr val="1F3864"/>
+                        <a:rPr sz="600" b="1" i="0">
+                          <a:solidFill>
+                            <a:srgbClr val="262626"/>
                           </a:solidFill>
                           <a:latin typeface="Calibri"/>
                         </a:rPr>
@@ -21149,18 +21518,18 @@
                   </a:txBody>
                   <a:tcPr anchor="ctr" marL="45720" marR="36576" marT="9144" marB="9144">
                     <a:solidFill>
-                      <a:srgbClr val="D9E2F3"/>
-                    </a:solidFill>
-                  </a:tcPr>
-                </a:tc>
-                <a:tc>
-                  <a:txBody>
-                    <a:bodyPr wrap="square"/>
-                    <a:lstStyle/>
-                    <a:p>
-                      <a:pPr algn="ctr"/>
-                      <a:r>
-                        <a:rPr sz="620" b="0" i="0">
+                      <a:srgbClr val="FBEFCB"/>
+                    </a:solidFill>
+                  </a:tcPr>
+                </a:tc>
+                <a:tc>
+                  <a:txBody>
+                    <a:bodyPr wrap="square"/>
+                    <a:lstStyle/>
+                    <a:p>
+                      <a:pPr algn="ctr"/>
+                      <a:r>
+                        <a:rPr sz="600" b="0" i="0">
                           <a:solidFill>
                             <a:srgbClr val="262626"/>
                           </a:solidFill>
@@ -21183,7 +21552,7 @@
                     <a:p>
                       <a:pPr algn="ctr"/>
                       <a:r>
-                        <a:rPr sz="620" b="0" i="0">
+                        <a:rPr sz="600" b="0" i="0">
                           <a:solidFill>
                             <a:srgbClr val="262626"/>
                           </a:solidFill>
@@ -21206,7 +21575,7 @@
                     <a:p>
                       <a:pPr algn="ctr"/>
                       <a:r>
-                        <a:rPr sz="620" b="0" i="0">
+                        <a:rPr sz="600" b="0" i="0">
                           <a:solidFill>
                             <a:srgbClr val="262626"/>
                           </a:solidFill>
@@ -21229,7 +21598,7 @@
                     <a:p>
                       <a:pPr algn="ctr"/>
                       <a:r>
-                        <a:rPr sz="620" b="0" i="0">
+                        <a:rPr sz="600" b="0" i="0">
                           <a:solidFill>
                             <a:srgbClr val="262626"/>
                           </a:solidFill>
@@ -21252,7 +21621,7 @@
                     <a:p>
                       <a:pPr algn="ctr"/>
                       <a:r>
-                        <a:rPr sz="620" b="0" i="0">
+                        <a:rPr sz="600" b="0" i="0">
                           <a:solidFill>
                             <a:srgbClr val="262626"/>
                           </a:solidFill>
@@ -21275,7 +21644,7 @@
                     <a:p>
                       <a:pPr algn="ctr"/>
                       <a:r>
-                        <a:rPr sz="620" b="0" i="0">
+                        <a:rPr sz="600" b="0" i="0">
                           <a:solidFill>
                             <a:srgbClr val="262626"/>
                           </a:solidFill>
@@ -21287,7 +21656,7 @@
                     <a:p>
                       <a:pPr algn="ctr"/>
                       <a:r>
-                        <a:rPr sz="620" b="0" i="0">
+                        <a:rPr sz="600" b="0" i="0">
                           <a:solidFill>
                             <a:srgbClr val="262626"/>
                           </a:solidFill>
@@ -21310,7 +21679,7 @@
                     <a:p>
                       <a:pPr algn="ctr"/>
                       <a:r>
-                        <a:rPr sz="620" b="0" i="0">
+                        <a:rPr sz="600" b="0" i="0">
                           <a:solidFill>
                             <a:srgbClr val="262626"/>
                           </a:solidFill>
@@ -21333,7 +21702,7 @@
                     <a:p>
                       <a:pPr algn="ctr"/>
                       <a:r>
-                        <a:rPr sz="620" b="0" i="0">
+                        <a:rPr sz="600" b="0" i="0">
                           <a:solidFill>
                             <a:srgbClr val="262626"/>
                           </a:solidFill>
@@ -21350,7 +21719,7 @@
                   </a:tcPr>
                 </a:tc>
               </a:tr>
-              <a:tr h="225856">
+              <a:tr h="212140">
                 <a:tc>
                   <a:txBody>
                     <a:bodyPr wrap="square"/>
@@ -21358,9 +21727,9 @@
                     <a:p>
                       <a:pPr algn="l"/>
                       <a:r>
-                        <a:rPr sz="620" b="1" i="0">
-                          <a:solidFill>
-                            <a:srgbClr val="1F3864"/>
+                        <a:rPr sz="600" b="1" i="0">
+                          <a:solidFill>
+                            <a:srgbClr val="262626"/>
                           </a:solidFill>
                           <a:latin typeface="Calibri"/>
                         </a:rPr>
@@ -21370,18 +21739,18 @@
                   </a:txBody>
                   <a:tcPr anchor="ctr" marL="45720" marR="36576" marT="9144" marB="9144">
                     <a:solidFill>
-                      <a:srgbClr val="D9E2F3"/>
-                    </a:solidFill>
-                  </a:tcPr>
-                </a:tc>
-                <a:tc>
-                  <a:txBody>
-                    <a:bodyPr wrap="square"/>
-                    <a:lstStyle/>
-                    <a:p>
-                      <a:pPr algn="ctr"/>
-                      <a:r>
-                        <a:rPr sz="620" b="0" i="0">
+                      <a:srgbClr val="FBEFCB"/>
+                    </a:solidFill>
+                  </a:tcPr>
+                </a:tc>
+                <a:tc>
+                  <a:txBody>
+                    <a:bodyPr wrap="square"/>
+                    <a:lstStyle/>
+                    <a:p>
+                      <a:pPr algn="ctr"/>
+                      <a:r>
+                        <a:rPr sz="600" b="0" i="0">
                           <a:solidFill>
                             <a:srgbClr val="262626"/>
                           </a:solidFill>
@@ -21404,7 +21773,7 @@
                     <a:p>
                       <a:pPr algn="ctr"/>
                       <a:r>
-                        <a:rPr sz="620" b="0" i="0">
+                        <a:rPr sz="600" b="0" i="0">
                           <a:solidFill>
                             <a:srgbClr val="262626"/>
                           </a:solidFill>
@@ -21416,7 +21785,7 @@
                     <a:p>
                       <a:pPr algn="ctr"/>
                       <a:r>
-                        <a:rPr sz="620" b="0" i="0">
+                        <a:rPr sz="600" b="0" i="0">
                           <a:solidFill>
                             <a:srgbClr val="262626"/>
                           </a:solidFill>
@@ -21439,7 +21808,7 @@
                     <a:p>
                       <a:pPr algn="ctr"/>
                       <a:r>
-                        <a:rPr sz="620" b="0" i="0">
+                        <a:rPr sz="600" b="0" i="0">
                           <a:solidFill>
                             <a:srgbClr val="262626"/>
                           </a:solidFill>
@@ -21451,7 +21820,7 @@
                     <a:p>
                       <a:pPr algn="ctr"/>
                       <a:r>
-                        <a:rPr sz="620" b="0" i="0">
+                        <a:rPr sz="600" b="0" i="0">
                           <a:solidFill>
                             <a:srgbClr val="262626"/>
                           </a:solidFill>
@@ -21474,7 +21843,7 @@
                     <a:p>
                       <a:pPr algn="ctr"/>
                       <a:r>
-                        <a:rPr sz="620" b="0" i="0">
+                        <a:rPr sz="600" b="0" i="0">
                           <a:solidFill>
                             <a:srgbClr val="262626"/>
                           </a:solidFill>
@@ -21486,7 +21855,7 @@
                     <a:p>
                       <a:pPr algn="ctr"/>
                       <a:r>
-                        <a:rPr sz="620" b="0" i="0">
+                        <a:rPr sz="600" b="0" i="0">
                           <a:solidFill>
                             <a:srgbClr val="262626"/>
                           </a:solidFill>
@@ -21509,7 +21878,7 @@
                     <a:p>
                       <a:pPr algn="ctr"/>
                       <a:r>
-                        <a:rPr sz="620" b="0" i="0">
+                        <a:rPr sz="600" b="0" i="0">
                           <a:solidFill>
                             <a:srgbClr val="262626"/>
                           </a:solidFill>
@@ -21521,7 +21890,7 @@
                     <a:p>
                       <a:pPr algn="ctr"/>
                       <a:r>
-                        <a:rPr sz="620" b="0" i="0">
+                        <a:rPr sz="600" b="0" i="0">
                           <a:solidFill>
                             <a:srgbClr val="262626"/>
                           </a:solidFill>
@@ -21544,7 +21913,7 @@
                     <a:p>
                       <a:pPr algn="ctr"/>
                       <a:r>
-                        <a:rPr sz="620" b="0" i="0">
+                        <a:rPr sz="600" b="0" i="0">
                           <a:solidFill>
                             <a:srgbClr val="262626"/>
                           </a:solidFill>
@@ -21556,7 +21925,7 @@
                     <a:p>
                       <a:pPr algn="ctr"/>
                       <a:r>
-                        <a:rPr sz="620" b="0" i="0">
+                        <a:rPr sz="600" b="0" i="0">
                           <a:solidFill>
                             <a:srgbClr val="262626"/>
                           </a:solidFill>
@@ -21579,7 +21948,7 @@
                     <a:p>
                       <a:pPr algn="ctr"/>
                       <a:r>
-                        <a:rPr sz="620" b="0" i="0">
+                        <a:rPr sz="600" b="0" i="0">
                           <a:solidFill>
                             <a:srgbClr val="262626"/>
                           </a:solidFill>
@@ -21591,7 +21960,7 @@
                     <a:p>
                       <a:pPr algn="ctr"/>
                       <a:r>
-                        <a:rPr sz="620" b="0" i="0">
+                        <a:rPr sz="600" b="0" i="0">
                           <a:solidFill>
                             <a:srgbClr val="262626"/>
                           </a:solidFill>
@@ -21614,7 +21983,7 @@
                     <a:p>
                       <a:pPr algn="ctr"/>
                       <a:r>
-                        <a:rPr sz="620" b="0" i="0">
+                        <a:rPr sz="600" b="0" i="0">
                           <a:solidFill>
                             <a:srgbClr val="262626"/>
                           </a:solidFill>
@@ -21626,7 +21995,7 @@
                     <a:p>
                       <a:pPr algn="ctr"/>
                       <a:r>
-                        <a:rPr sz="620" b="0" i="0">
+                        <a:rPr sz="600" b="0" i="0">
                           <a:solidFill>
                             <a:srgbClr val="262626"/>
                           </a:solidFill>

</xml_diff>

<commit_message>
Embed property/comp photos, add schematic locator map, tighten consistency
Embed the first batch of building photos: 2300 N hero on the cover, exterior +
roof terrace on Property Overview, and 888 16th / Hamilton Square in the first
two Class-A comp columns (matrix now supports a photos= arg per column).
Generate a clean schematic West End locator map (make_map.py) for the Location
slide. Standardize the one outlier sub-header size for consistency.

Co-Authored-By: Claude Opus 4.8 <noreply@anthropic.com>
Claude-Session: https://claude.ai/code/session_01618gwRtNT4bFmajXdLmDkH
</commit_message>
<xml_diff>
--- a/equity-deck/2300_N_Street_NW_Investment_Overview.pptx
+++ b/equity-deck/2300_N_Street_NW_Investment_Overview.pptx
@@ -3148,12 +3148,20 @@
           </a:p>
         </p:txBody>
       </p:sp>
-      <p:sp>
-        <p:nvSpPr>
-          <p:cNvPr id="3" name="Rectangle 2"/>
-          <p:cNvSpPr/>
+      <p:pic>
+        <p:nvPicPr>
+          <p:cNvPr id="3" name="Picture 2" descr="c_555721ea6ef0678e.jpg"/>
+          <p:cNvPicPr>
+            <a:picLocks noChangeAspect="1"/>
+          </p:cNvPicPr>
           <p:nvPr/>
-        </p:nvSpPr>
+        </p:nvPicPr>
+        <p:blipFill>
+          <a:blip r:embed="rId2"/>
+          <a:stretch>
+            <a:fillRect/>
+          </a:stretch>
+        </p:blipFill>
         <p:spPr>
           <a:xfrm>
             <a:off x="4160520" y="0"/>
@@ -3162,74 +3170,11 @@
           <a:prstGeom prst="rect">
             <a:avLst/>
           </a:prstGeom>
-          <a:solidFill>
-            <a:srgbClr val="1A1A1A"/>
-          </a:solidFill>
-          <a:ln>
-            <a:noFill/>
-          </a:ln>
-          <a:effectLst/>
         </p:spPr>
-        <p:style>
-          <a:lnRef idx="1">
-            <a:schemeClr val="accent1"/>
-          </a:lnRef>
-          <a:fillRef idx="3">
-            <a:schemeClr val="accent1"/>
-          </a:fillRef>
-          <a:effectRef idx="2">
-            <a:schemeClr val="accent1"/>
-          </a:effectRef>
-          <a:fontRef idx="minor">
-            <a:schemeClr val="lt1"/>
-          </a:fontRef>
-        </p:style>
-        <p:txBody>
-          <a:bodyPr rtlCol="0" anchor="ctr"/>
-          <a:lstStyle/>
-          <a:p>
-            <a:pPr algn="ctr"/>
-          </a:p>
-        </p:txBody>
-      </p:sp>
+      </p:pic>
       <p:sp>
         <p:nvSpPr>
           <p:cNvPr id="4" name="TextBox 3"/>
-          <p:cNvSpPr txBox="1"/>
-          <p:nvPr/>
-        </p:nvSpPr>
-        <p:spPr>
-          <a:xfrm>
-            <a:off x="4160520" y="2286000"/>
-            <a:ext cx="4983480" cy="548640"/>
-          </a:xfrm>
-          <a:prstGeom prst="rect">
-            <a:avLst/>
-          </a:prstGeom>
-          <a:noFill/>
-        </p:spPr>
-        <p:txBody>
-          <a:bodyPr wrap="square" anchor="t" lIns="0" rIns="0" tIns="0" bIns="0">
-            <a:spAutoFit/>
-          </a:bodyPr>
-          <a:lstStyle/>
-          <a:p>
-            <a:pPr algn="ctr"/>
-            <a:r>
-              <a:rPr sz="1100" b="0" i="1">
-                <a:solidFill>
-                  <a:srgbClr val="8C8C8C"/>
-                </a:solidFill>
-                <a:latin typeface="Calibri"/>
-              </a:rPr>
-              <a:t>[ Insert 2300 N Street property photograph ]</a:t>
-            </a:r>
-          </a:p>
-        </p:txBody>
-      </p:sp>
-      <p:sp>
-        <p:nvSpPr>
-          <p:cNvPr id="5" name="TextBox 4"/>
           <p:cNvSpPr txBox="1"/>
           <p:nvPr/>
         </p:nvSpPr>
@@ -3264,7 +3209,7 @@
       </p:sp>
       <p:sp>
         <p:nvSpPr>
-          <p:cNvPr id="6" name="TextBox 5"/>
+          <p:cNvPr id="5" name="TextBox 4"/>
           <p:cNvSpPr txBox="1"/>
           <p:nvPr/>
         </p:nvSpPr>
@@ -3299,7 +3244,7 @@
       </p:sp>
       <p:sp>
         <p:nvSpPr>
-          <p:cNvPr id="7" name="TextBox 6"/>
+          <p:cNvPr id="6" name="TextBox 5"/>
           <p:cNvSpPr txBox="1"/>
           <p:nvPr/>
         </p:nvSpPr>
@@ -3334,7 +3279,7 @@
       </p:sp>
       <p:sp>
         <p:nvSpPr>
-          <p:cNvPr id="8" name="TextBox 7"/>
+          <p:cNvPr id="7" name="TextBox 6"/>
           <p:cNvSpPr txBox="1"/>
           <p:nvPr/>
         </p:nvSpPr>
@@ -3389,7 +3334,7 @@
       </p:sp>
       <p:sp>
         <p:nvSpPr>
-          <p:cNvPr id="9" name="TextBox 8"/>
+          <p:cNvPr id="8" name="TextBox 7"/>
           <p:cNvSpPr txBox="1"/>
           <p:nvPr/>
         </p:nvSpPr>
@@ -3424,7 +3369,7 @@
       </p:sp>
       <p:sp>
         <p:nvSpPr>
-          <p:cNvPr id="10" name="TextBox 9"/>
+          <p:cNvPr id="9" name="TextBox 8"/>
           <p:cNvSpPr txBox="1"/>
           <p:nvPr/>
         </p:nvSpPr>
@@ -10639,44 +10584,44 @@
                     <a:bodyPr wrap="square"/>
                     <a:lstStyle/>
                     <a:p>
-                      <a:pPr algn="ctr"/>
-                      <a:r>
-                        <a:rPr sz="600" b="0" i="1">
+                      <a:pPr algn="l"/>
+                      <a:r>
+                        <a:rPr sz="600" b="0" i="0">
                           <a:solidFill>
                             <a:srgbClr val="595959"/>
                           </a:solidFill>
                           <a:latin typeface="Calibri"/>
                         </a:rPr>
-                        <a:t>[ photo ]</a:t>
-                      </a:r>
-                    </a:p>
-                  </a:txBody>
-                  <a:tcPr anchor="ctr" marL="45720" marR="36576" marT="9144" marB="9144">
-                    <a:solidFill>
-                      <a:srgbClr val="DDDDDD"/>
-                    </a:solidFill>
-                  </a:tcPr>
-                </a:tc>
-                <a:tc>
-                  <a:txBody>
-                    <a:bodyPr wrap="square"/>
-                    <a:lstStyle/>
-                    <a:p>
-                      <a:pPr algn="ctr"/>
-                      <a:r>
-                        <a:rPr sz="600" b="0" i="1">
+                        <a:t/>
+                      </a:r>
+                    </a:p>
+                  </a:txBody>
+                  <a:tcPr anchor="ctr" marL="45720" marR="36576" marT="9144" marB="9144">
+                    <a:solidFill>
+                      <a:srgbClr val="FFFFFF"/>
+                    </a:solidFill>
+                  </a:tcPr>
+                </a:tc>
+                <a:tc>
+                  <a:txBody>
+                    <a:bodyPr wrap="square"/>
+                    <a:lstStyle/>
+                    <a:p>
+                      <a:pPr algn="l"/>
+                      <a:r>
+                        <a:rPr sz="600" b="0" i="0">
                           <a:solidFill>
                             <a:srgbClr val="595959"/>
                           </a:solidFill>
                           <a:latin typeface="Calibri"/>
                         </a:rPr>
-                        <a:t>[ photo ]</a:t>
-                      </a:r>
-                    </a:p>
-                  </a:txBody>
-                  <a:tcPr anchor="ctr" marL="45720" marR="36576" marT="9144" marB="9144">
-                    <a:solidFill>
-                      <a:srgbClr val="DDDDDD"/>
+                        <a:t/>
+                      </a:r>
+                    </a:p>
+                  </a:txBody>
+                  <a:tcPr anchor="ctr" marL="45720" marR="36576" marT="9144" marB="9144">
+                    <a:solidFill>
+                      <a:srgbClr val="FFFFFF"/>
                     </a:solidFill>
                   </a:tcPr>
                 </a:tc>
@@ -13694,6 +13639,54 @@
           </a:graphicData>
         </a:graphic>
       </p:graphicFrame>
+      <p:pic>
+        <p:nvPicPr>
+          <p:cNvPr id="13" name="Picture 12" descr="c_3727707438865be8.jpg"/>
+          <p:cNvPicPr>
+            <a:picLocks noChangeAspect="1"/>
+          </p:cNvPicPr>
+          <p:nvPr/>
+        </p:nvPicPr>
+        <p:blipFill>
+          <a:blip r:embed="rId2"/>
+          <a:stretch>
+            <a:fillRect/>
+          </a:stretch>
+        </p:blipFill>
+        <p:spPr>
+          <a:xfrm>
+            <a:off x="1280160" y="2011680"/>
+            <a:ext cx="679981" cy="512064"/>
+          </a:xfrm>
+          <a:prstGeom prst="rect">
+            <a:avLst/>
+          </a:prstGeom>
+        </p:spPr>
+      </p:pic>
+      <p:pic>
+        <p:nvPicPr>
+          <p:cNvPr id="14" name="Picture 13" descr="c_70acd9340bb65732.jpg"/>
+          <p:cNvPicPr>
+            <a:picLocks noChangeAspect="1"/>
+          </p:cNvPicPr>
+          <p:nvPr/>
+        </p:nvPicPr>
+        <p:blipFill>
+          <a:blip r:embed="rId3"/>
+          <a:stretch>
+            <a:fillRect/>
+          </a:stretch>
+        </p:blipFill>
+        <p:spPr>
+          <a:xfrm>
+            <a:off x="1960141" y="2011680"/>
+            <a:ext cx="679981" cy="512064"/>
+          </a:xfrm>
+          <a:prstGeom prst="rect">
+            <a:avLst/>
+          </a:prstGeom>
+        </p:spPr>
+      </p:pic>
     </p:spTree>
   </p:cSld>
   <p:clrMapOvr>
@@ -23959,12 +23952,20 @@
           </a:graphicData>
         </a:graphic>
       </p:graphicFrame>
-      <p:sp>
-        <p:nvSpPr>
-          <p:cNvPr id="10" name="Rectangle 9"/>
-          <p:cNvSpPr/>
+      <p:pic>
+        <p:nvPicPr>
+          <p:cNvPr id="10" name="Picture 9" descr="c_5005a934e83eadda.jpg"/>
+          <p:cNvPicPr>
+            <a:picLocks noChangeAspect="1"/>
+          </p:cNvPicPr>
           <p:nvPr/>
-        </p:nvSpPr>
+        </p:nvPicPr>
+        <p:blipFill>
+          <a:blip r:embed="rId2"/>
+          <a:stretch>
+            <a:fillRect/>
+          </a:stretch>
+        </p:blipFill>
         <p:spPr>
           <a:xfrm>
             <a:off x="5532120" y="960120"/>
@@ -23973,77 +23974,22 @@
           <a:prstGeom prst="rect">
             <a:avLst/>
           </a:prstGeom>
-          <a:solidFill>
-            <a:srgbClr val="D9D9D9"/>
-          </a:solidFill>
-          <a:ln>
-            <a:noFill/>
-          </a:ln>
-          <a:effectLst/>
         </p:spPr>
-        <p:style>
-          <a:lnRef idx="1">
-            <a:schemeClr val="accent1"/>
-          </a:lnRef>
-          <a:fillRef idx="3">
-            <a:schemeClr val="accent1"/>
-          </a:fillRef>
-          <a:effectRef idx="2">
-            <a:schemeClr val="accent1"/>
-          </a:effectRef>
-          <a:fontRef idx="minor">
-            <a:schemeClr val="lt1"/>
-          </a:fontRef>
-        </p:style>
-        <p:txBody>
-          <a:bodyPr rtlCol="0" anchor="ctr"/>
-          <a:lstStyle/>
-          <a:p>
-            <a:pPr algn="ctr"/>
-          </a:p>
-        </p:txBody>
-      </p:sp>
-      <p:sp>
-        <p:nvSpPr>
-          <p:cNvPr id="11" name="TextBox 10"/>
-          <p:cNvSpPr txBox="1"/>
+      </p:pic>
+      <p:pic>
+        <p:nvPicPr>
+          <p:cNvPr id="11" name="Picture 10" descr="c_31d48de1e9a1395f.jpg"/>
+          <p:cNvPicPr>
+            <a:picLocks noChangeAspect="1"/>
+          </p:cNvPicPr>
           <p:nvPr/>
-        </p:nvSpPr>
-        <p:spPr>
-          <a:xfrm>
-            <a:off x="5532120" y="1737360"/>
-            <a:ext cx="3227832" cy="365760"/>
-          </a:xfrm>
-          <a:prstGeom prst="rect">
-            <a:avLst/>
-          </a:prstGeom>
-          <a:noFill/>
-        </p:spPr>
-        <p:txBody>
-          <a:bodyPr wrap="square" anchor="t" lIns="0" rIns="0" tIns="0" bIns="0">
-            <a:spAutoFit/>
-          </a:bodyPr>
-          <a:lstStyle/>
-          <a:p>
-            <a:pPr algn="ctr"/>
-            <a:r>
-              <a:rPr sz="1000" b="0" i="1">
-                <a:solidFill>
-                  <a:srgbClr val="595959"/>
-                </a:solidFill>
-                <a:latin typeface="Calibri"/>
-              </a:rPr>
-              <a:t>[ Property exterior photograph ]</a:t>
-            </a:r>
-          </a:p>
-        </p:txBody>
-      </p:sp>
-      <p:sp>
-        <p:nvSpPr>
-          <p:cNvPr id="12" name="Rectangle 11"/>
-          <p:cNvSpPr/>
-          <p:nvPr/>
-        </p:nvSpPr>
+        </p:nvPicPr>
+        <p:blipFill>
+          <a:blip r:embed="rId3"/>
+          <a:stretch>
+            <a:fillRect/>
+          </a:stretch>
+        </p:blipFill>
         <p:spPr>
           <a:xfrm>
             <a:off x="5532120" y="2788920"/>
@@ -24052,71 +23998,8 @@
           <a:prstGeom prst="rect">
             <a:avLst/>
           </a:prstGeom>
-          <a:solidFill>
-            <a:srgbClr val="D9D9D9"/>
-          </a:solidFill>
-          <a:ln>
-            <a:noFill/>
-          </a:ln>
-          <a:effectLst/>
         </p:spPr>
-        <p:style>
-          <a:lnRef idx="1">
-            <a:schemeClr val="accent1"/>
-          </a:lnRef>
-          <a:fillRef idx="3">
-            <a:schemeClr val="accent1"/>
-          </a:fillRef>
-          <a:effectRef idx="2">
-            <a:schemeClr val="accent1"/>
-          </a:effectRef>
-          <a:fontRef idx="minor">
-            <a:schemeClr val="lt1"/>
-          </a:fontRef>
-        </p:style>
-        <p:txBody>
-          <a:bodyPr rtlCol="0" anchor="ctr"/>
-          <a:lstStyle/>
-          <a:p>
-            <a:pPr algn="ctr"/>
-          </a:p>
-        </p:txBody>
-      </p:sp>
-      <p:sp>
-        <p:nvSpPr>
-          <p:cNvPr id="13" name="TextBox 12"/>
-          <p:cNvSpPr txBox="1"/>
-          <p:nvPr/>
-        </p:nvSpPr>
-        <p:spPr>
-          <a:xfrm>
-            <a:off x="5532120" y="3566160"/>
-            <a:ext cx="3227832" cy="365760"/>
-          </a:xfrm>
-          <a:prstGeom prst="rect">
-            <a:avLst/>
-          </a:prstGeom>
-          <a:noFill/>
-        </p:spPr>
-        <p:txBody>
-          <a:bodyPr wrap="square" anchor="t" lIns="0" rIns="0" tIns="0" bIns="0">
-            <a:spAutoFit/>
-          </a:bodyPr>
-          <a:lstStyle/>
-          <a:p>
-            <a:pPr algn="ctr"/>
-            <a:r>
-              <a:rPr sz="1000" b="0" i="1">
-                <a:solidFill>
-                  <a:srgbClr val="595959"/>
-                </a:solidFill>
-                <a:latin typeface="Calibri"/>
-              </a:rPr>
-              <a:t>[ Roof terrace / lobby photograph ]</a:t>
-            </a:r>
-          </a:p>
-        </p:txBody>
-      </p:sp>
+      </p:pic>
     </p:spTree>
   </p:cSld>
   <p:clrMapOvr>
@@ -24363,12 +24246,20 @@
           </a:p>
         </p:txBody>
       </p:sp>
-      <p:sp>
-        <p:nvSpPr>
-          <p:cNvPr id="8" name="Rectangle 7"/>
-          <p:cNvSpPr/>
+      <p:pic>
+        <p:nvPicPr>
+          <p:cNvPr id="8" name="Picture 7" descr="c_72c27656f7b7218a.jpg"/>
+          <p:cNvPicPr>
+            <a:picLocks noChangeAspect="1"/>
+          </p:cNvPicPr>
           <p:nvPr/>
-        </p:nvSpPr>
+        </p:nvPicPr>
+        <p:blipFill>
+          <a:blip r:embed="rId2"/>
+          <a:stretch>
+            <a:fillRect/>
+          </a:stretch>
+        </p:blipFill>
         <p:spPr>
           <a:xfrm>
             <a:off x="384048" y="960120"/>
@@ -24377,74 +24268,11 @@
           <a:prstGeom prst="rect">
             <a:avLst/>
           </a:prstGeom>
-          <a:solidFill>
-            <a:srgbClr val="D9D9D9"/>
-          </a:solidFill>
-          <a:ln>
-            <a:noFill/>
-          </a:ln>
-          <a:effectLst/>
         </p:spPr>
-        <p:style>
-          <a:lnRef idx="1">
-            <a:schemeClr val="accent1"/>
-          </a:lnRef>
-          <a:fillRef idx="3">
-            <a:schemeClr val="accent1"/>
-          </a:fillRef>
-          <a:effectRef idx="2">
-            <a:schemeClr val="accent1"/>
-          </a:effectRef>
-          <a:fontRef idx="minor">
-            <a:schemeClr val="lt1"/>
-          </a:fontRef>
-        </p:style>
-        <p:txBody>
-          <a:bodyPr rtlCol="0" anchor="ctr"/>
-          <a:lstStyle/>
-          <a:p>
-            <a:pPr algn="ctr"/>
-          </a:p>
-        </p:txBody>
-      </p:sp>
+      </p:pic>
       <p:sp>
         <p:nvSpPr>
-          <p:cNvPr id="9" name="TextBox 8"/>
-          <p:cNvSpPr txBox="1"/>
-          <p:nvPr/>
-        </p:nvSpPr>
-        <p:spPr>
-          <a:xfrm>
-            <a:off x="384048" y="2651760"/>
-            <a:ext cx="5257800" cy="365760"/>
-          </a:xfrm>
-          <a:prstGeom prst="rect">
-            <a:avLst/>
-          </a:prstGeom>
-          <a:noFill/>
-        </p:spPr>
-        <p:txBody>
-          <a:bodyPr wrap="square" anchor="t" lIns="0" rIns="0" tIns="0" bIns="0">
-            <a:spAutoFit/>
-          </a:bodyPr>
-          <a:lstStyle/>
-          <a:p>
-            <a:pPr algn="ctr"/>
-            <a:r>
-              <a:rPr sz="1100" b="0" i="1">
-                <a:solidFill>
-                  <a:srgbClr val="595959"/>
-                </a:solidFill>
-                <a:latin typeface="Calibri"/>
-              </a:rPr>
-              <a:t>[ Insert West End aerial / location map ]</a:t>
-            </a:r>
-          </a:p>
-        </p:txBody>
-      </p:sp>
-      <p:sp>
-        <p:nvSpPr>
-          <p:cNvPr id="10" name="Rectangle 9"/>
+          <p:cNvPr id="9" name="Rectangle 8"/>
           <p:cNvSpPr/>
           <p:nvPr/>
         </p:nvSpPr>
@@ -24488,7 +24316,7 @@
       </p:sp>
       <p:sp>
         <p:nvSpPr>
-          <p:cNvPr id="11" name="TextBox 10"/>
+          <p:cNvPr id="10" name="TextBox 9"/>
           <p:cNvSpPr txBox="1"/>
           <p:nvPr/>
         </p:nvSpPr>
@@ -24523,7 +24351,7 @@
       </p:sp>
       <p:sp>
         <p:nvSpPr>
-          <p:cNvPr id="12" name="TextBox 11"/>
+          <p:cNvPr id="11" name="TextBox 10"/>
           <p:cNvSpPr txBox="1"/>
           <p:nvPr/>
         </p:nvSpPr>
@@ -24731,7 +24559,7 @@
       </p:sp>
       <p:sp>
         <p:nvSpPr>
-          <p:cNvPr id="13" name="TextBox 12"/>
+          <p:cNvPr id="12" name="TextBox 11"/>
           <p:cNvSpPr txBox="1"/>
           <p:nvPr/>
         </p:nvSpPr>
@@ -24759,7 +24587,7 @@
                 </a:solidFill>
                 <a:latin typeface="Calibri"/>
               </a:rPr>
-              <a:t>Source: CoStar (7/1/2026).</a:t>
+              <a:t>Location highlights per CoStar (7/1/2026). Map is a schematic for orientation, not to scale.</a:t>
             </a:r>
           </a:p>
         </p:txBody>
@@ -30534,7 +30362,7 @@
           <a:p>
             <a:pPr algn="l"/>
             <a:r>
-              <a:rPr sz="1400" b="1" i="0">
+              <a:rPr sz="1300" b="1" i="0">
                 <a:solidFill>
                   <a:srgbClr val="262626"/>
                 </a:solidFill>

</xml_diff>